<commit_message>
Costa Rica early-bird carousel (3 Nov): six-slide editable deck in the trifold look
Real Costa Rica workshop photos (Oct 2025 and Jul 2024, catalog picks),
flat Food Web Green, Soil Brown, cream and Education Blue boxes, the
green box running from slide 1 into the band on slide 2. Every photo,
box, text and the logo is its own layer; each slide's photo file is in
the speaker notes.

Co-Authored-By: Claude Opus 5.5 <noreply@anthropic.com>
Claude-Session: https://claude.ai/code/session_01QZnNNxz3UXnFefobAaUWFn
</commit_message>
<xml_diff>
--- a/apps/web/public/wormhole/decks/03-11-2026-costa-rica-early-bird.pptx
+++ b/apps/web/public/wormhole/decks/03-11-2026-costa-rica-early-bird.pptx
@@ -9,6 +9,8 @@
     <p:sldId id="257" r:id="rId8"/>
     <p:sldId id="258" r:id="rId9"/>
     <p:sldId id="259" r:id="rId10"/>
+    <p:sldId id="260" r:id="rId11"/>
+    <p:sldId id="261" r:id="rId12"/>
   </p:sldIdLst>
   <p:sldSz cx="10287000" cy="12858750" type="screen4x3"/>
   <p:notesSz cx="6858000" cy="9144000"/>
@@ -108,6 +110,806 @@
     </a:lvl9pPr>
   </p:defaultTextStyle>
 </p:presentation>
+</file>
+
+<file path=ppt/notesMasters/notesMaster1.xml><?xml version="1.0" encoding="utf-8"?>
+<p:notesMaster xmlns:a="http://schemas.openxmlformats.org/drawingml/2006/main" xmlns:p="http://schemas.openxmlformats.org/presentationml/2006/main" xmlns:r="http://schemas.openxmlformats.org/officeDocument/2006/relationships">
+  <p:cSld>
+    <p:bg>
+      <p:bgRef idx="1001">
+        <a:schemeClr val="bg1"/>
+      </p:bgRef>
+    </p:bg>
+    <p:spTree>
+      <p:nvGrpSpPr>
+        <p:cNvPr id="1" name=""/>
+        <p:cNvGrpSpPr/>
+        <p:nvPr/>
+      </p:nvGrpSpPr>
+      <p:grpSpPr>
+        <a:xfrm>
+          <a:off x="0" y="0"/>
+          <a:ext cx="0" cy="0"/>
+          <a:chOff x="0" y="0"/>
+          <a:chExt cx="0" cy="0"/>
+        </a:xfrm>
+      </p:grpSpPr>
+      <p:sp>
+        <p:nvSpPr>
+          <p:cNvPr id="2" name="Header Placeholder 1"/>
+          <p:cNvSpPr>
+            <a:spLocks noGrp="1"/>
+          </p:cNvSpPr>
+          <p:nvPr>
+            <p:ph type="hdr" sz="quarter"/>
+          </p:nvPr>
+        </p:nvSpPr>
+        <p:spPr>
+          <a:xfrm>
+            <a:off x="0" y="0"/>
+            <a:ext cx="2971800" cy="457200"/>
+          </a:xfrm>
+          <a:prstGeom prst="rect">
+            <a:avLst/>
+          </a:prstGeom>
+        </p:spPr>
+        <p:txBody>
+          <a:bodyPr vert="horz" lIns="91440" tIns="45720" rIns="91440" bIns="45720" rtlCol="0"/>
+          <a:lstStyle>
+            <a:lvl1pPr algn="l">
+              <a:defRPr sz="1200"/>
+            </a:lvl1pPr>
+          </a:lstStyle>
+          <a:p>
+            <a:endParaRPr lang="en-US"/>
+          </a:p>
+        </p:txBody>
+      </p:sp>
+      <p:sp>
+        <p:nvSpPr>
+          <p:cNvPr id="3" name="Date Placeholder 2"/>
+          <p:cNvSpPr>
+            <a:spLocks noGrp="1"/>
+          </p:cNvSpPr>
+          <p:nvPr>
+            <p:ph type="dt" idx="1"/>
+          </p:nvPr>
+        </p:nvSpPr>
+        <p:spPr>
+          <a:xfrm>
+            <a:off x="3884613" y="0"/>
+            <a:ext cx="2971800" cy="457200"/>
+          </a:xfrm>
+          <a:prstGeom prst="rect">
+            <a:avLst/>
+          </a:prstGeom>
+        </p:spPr>
+        <p:txBody>
+          <a:bodyPr vert="horz" lIns="91440" tIns="45720" rIns="91440" bIns="45720" rtlCol="0"/>
+          <a:lstStyle>
+            <a:lvl1pPr algn="r">
+              <a:defRPr sz="1200"/>
+            </a:lvl1pPr>
+          </a:lstStyle>
+          <a:p>
+            <a:fld id="{0F89C1C7-3DCD-1040-A9CF-14679D8B5DDD}" type="datetimeFigureOut">
+              <a:rPr lang="en-US" smtClean="0"/>
+              <a:t>10/17/16</a:t>
+            </a:fld>
+            <a:endParaRPr lang="en-US"/>
+          </a:p>
+        </p:txBody>
+      </p:sp>
+      <p:sp>
+        <p:nvSpPr>
+          <p:cNvPr id="4" name="Slide Image Placeholder 3"/>
+          <p:cNvSpPr>
+            <a:spLocks noGrp="1" noRot="1" noChangeAspect="1"/>
+          </p:cNvSpPr>
+          <p:nvPr>
+            <p:ph type="sldImg" idx="2"/>
+          </p:nvPr>
+        </p:nvSpPr>
+        <p:spPr>
+          <a:xfrm>
+            <a:off x="1143000" y="685800"/>
+            <a:ext cx="4572000" cy="3429000"/>
+          </a:xfrm>
+          <a:prstGeom prst="rect">
+            <a:avLst/>
+          </a:prstGeom>
+          <a:noFill/>
+          <a:ln w="12700">
+            <a:solidFill>
+              <a:prstClr val="black"/>
+            </a:solidFill>
+          </a:ln>
+        </p:spPr>
+        <p:txBody>
+          <a:bodyPr vert="horz" lIns="91440" tIns="45720" rIns="91440" bIns="45720" rtlCol="0" anchor="ctr"/>
+          <a:lstStyle/>
+          <a:p>
+            <a:endParaRPr lang="en-US"/>
+          </a:p>
+        </p:txBody>
+      </p:sp>
+      <p:sp>
+        <p:nvSpPr>
+          <p:cNvPr id="5" name="Notes Placeholder 4"/>
+          <p:cNvSpPr>
+            <a:spLocks noGrp="1"/>
+          </p:cNvSpPr>
+          <p:nvPr>
+            <p:ph type="body" sz="quarter" idx="3"/>
+          </p:nvPr>
+        </p:nvSpPr>
+        <p:spPr>
+          <a:xfrm>
+            <a:off x="685800" y="4343400"/>
+            <a:ext cx="5486400" cy="4114800"/>
+          </a:xfrm>
+          <a:prstGeom prst="rect">
+            <a:avLst/>
+          </a:prstGeom>
+        </p:spPr>
+        <p:txBody>
+          <a:bodyPr vert="horz" lIns="91440" tIns="45720" rIns="91440" bIns="45720" rtlCol="0"/>
+          <a:lstStyle/>
+          <a:p>
+            <a:pPr lvl="0"/>
+            <a:r>
+              <a:rPr lang="en-US" smtClean="0"/>
+              <a:t>Click to edit Master text styles</a:t>
+            </a:r>
+          </a:p>
+          <a:p>
+            <a:pPr lvl="1"/>
+            <a:r>
+              <a:rPr lang="en-US" smtClean="0"/>
+              <a:t>Second level</a:t>
+            </a:r>
+          </a:p>
+          <a:p>
+            <a:pPr lvl="2"/>
+            <a:r>
+              <a:rPr lang="en-US" smtClean="0"/>
+              <a:t>Third level</a:t>
+            </a:r>
+          </a:p>
+          <a:p>
+            <a:pPr lvl="3"/>
+            <a:r>
+              <a:rPr lang="en-US" smtClean="0"/>
+              <a:t>Fourth level</a:t>
+            </a:r>
+          </a:p>
+          <a:p>
+            <a:pPr lvl="4"/>
+            <a:r>
+              <a:rPr lang="en-US" smtClean="0"/>
+              <a:t>Fifth level</a:t>
+            </a:r>
+            <a:endParaRPr lang="en-US"/>
+          </a:p>
+        </p:txBody>
+      </p:sp>
+      <p:sp>
+        <p:nvSpPr>
+          <p:cNvPr id="6" name="Footer Placeholder 5"/>
+          <p:cNvSpPr>
+            <a:spLocks noGrp="1"/>
+          </p:cNvSpPr>
+          <p:nvPr>
+            <p:ph type="ftr" sz="quarter" idx="4"/>
+          </p:nvPr>
+        </p:nvSpPr>
+        <p:spPr>
+          <a:xfrm>
+            <a:off x="0" y="8685213"/>
+            <a:ext cx="2971800" cy="457200"/>
+          </a:xfrm>
+          <a:prstGeom prst="rect">
+            <a:avLst/>
+          </a:prstGeom>
+        </p:spPr>
+        <p:txBody>
+          <a:bodyPr vert="horz" lIns="91440" tIns="45720" rIns="91440" bIns="45720" rtlCol="0" anchor="b"/>
+          <a:lstStyle>
+            <a:lvl1pPr algn="l">
+              <a:defRPr sz="1200"/>
+            </a:lvl1pPr>
+          </a:lstStyle>
+          <a:p>
+            <a:endParaRPr lang="en-US"/>
+          </a:p>
+        </p:txBody>
+      </p:sp>
+      <p:sp>
+        <p:nvSpPr>
+          <p:cNvPr id="7" name="Slide Number Placeholder 6"/>
+          <p:cNvSpPr>
+            <a:spLocks noGrp="1"/>
+          </p:cNvSpPr>
+          <p:nvPr>
+            <p:ph type="sldNum" sz="quarter" idx="5"/>
+          </p:nvPr>
+        </p:nvSpPr>
+        <p:spPr>
+          <a:xfrm>
+            <a:off x="3884613" y="8685213"/>
+            <a:ext cx="2971800" cy="457200"/>
+          </a:xfrm>
+          <a:prstGeom prst="rect">
+            <a:avLst/>
+          </a:prstGeom>
+        </p:spPr>
+        <p:txBody>
+          <a:bodyPr vert="horz" lIns="91440" tIns="45720" rIns="91440" bIns="45720" rtlCol="0" anchor="b"/>
+          <a:lstStyle>
+            <a:lvl1pPr algn="r">
+              <a:defRPr sz="1200"/>
+            </a:lvl1pPr>
+          </a:lstStyle>
+          <a:p>
+            <a:fld id="{BB5E49A5-4136-284D-997B-48E1D791AD67}" type="slidenum">
+              <a:rPr lang="en-US" smtClean="0"/>
+              <a:t>‹#›</a:t>
+            </a:fld>
+            <a:endParaRPr lang="en-US"/>
+          </a:p>
+        </p:txBody>
+      </p:sp>
+    </p:spTree>
+    <p:extLst>
+      <p:ext uri="{BB962C8B-B14F-4D97-AF65-F5344CB8AC3E}">
+        <p14:creationId xmlns:p14="http://schemas.microsoft.com/office/powerpoint/2010/main" val="2623252185"/>
+      </p:ext>
+    </p:extLst>
+  </p:cSld>
+  <p:clrMap bg1="lt1" tx1="dk1" bg2="lt2" tx2="dk2" accent1="accent1" accent2="accent2" accent3="accent3" accent4="accent4" accent5="accent5" accent6="accent6" hlink="hlink" folHlink="folHlink"/>
+  <p:notesStyle>
+    <a:lvl1pPr marL="0" algn="l" defTabSz="457200" rtl="0" eaLnBrk="1" latinLnBrk="0" hangingPunct="1">
+      <a:defRPr sz="1200" kern="1200">
+        <a:solidFill>
+          <a:schemeClr val="tx1"/>
+        </a:solidFill>
+        <a:latin typeface="+mn-lt"/>
+        <a:ea typeface="+mn-ea"/>
+        <a:cs typeface="+mn-cs"/>
+      </a:defRPr>
+    </a:lvl1pPr>
+    <a:lvl2pPr marL="457200" algn="l" defTabSz="457200" rtl="0" eaLnBrk="1" latinLnBrk="0" hangingPunct="1">
+      <a:defRPr sz="1200" kern="1200">
+        <a:solidFill>
+          <a:schemeClr val="tx1"/>
+        </a:solidFill>
+        <a:latin typeface="+mn-lt"/>
+        <a:ea typeface="+mn-ea"/>
+        <a:cs typeface="+mn-cs"/>
+      </a:defRPr>
+    </a:lvl2pPr>
+    <a:lvl3pPr marL="914400" algn="l" defTabSz="457200" rtl="0" eaLnBrk="1" latinLnBrk="0" hangingPunct="1">
+      <a:defRPr sz="1200" kern="1200">
+        <a:solidFill>
+          <a:schemeClr val="tx1"/>
+        </a:solidFill>
+        <a:latin typeface="+mn-lt"/>
+        <a:ea typeface="+mn-ea"/>
+        <a:cs typeface="+mn-cs"/>
+      </a:defRPr>
+    </a:lvl3pPr>
+    <a:lvl4pPr marL="1371600" algn="l" defTabSz="457200" rtl="0" eaLnBrk="1" latinLnBrk="0" hangingPunct="1">
+      <a:defRPr sz="1200" kern="1200">
+        <a:solidFill>
+          <a:schemeClr val="tx1"/>
+        </a:solidFill>
+        <a:latin typeface="+mn-lt"/>
+        <a:ea typeface="+mn-ea"/>
+        <a:cs typeface="+mn-cs"/>
+      </a:defRPr>
+    </a:lvl4pPr>
+    <a:lvl5pPr marL="1828800" algn="l" defTabSz="457200" rtl="0" eaLnBrk="1" latinLnBrk="0" hangingPunct="1">
+      <a:defRPr sz="1200" kern="1200">
+        <a:solidFill>
+          <a:schemeClr val="tx1"/>
+        </a:solidFill>
+        <a:latin typeface="+mn-lt"/>
+        <a:ea typeface="+mn-ea"/>
+        <a:cs typeface="+mn-cs"/>
+      </a:defRPr>
+    </a:lvl5pPr>
+    <a:lvl6pPr marL="2286000" algn="l" defTabSz="457200" rtl="0" eaLnBrk="1" latinLnBrk="0" hangingPunct="1">
+      <a:defRPr sz="1200" kern="1200">
+        <a:solidFill>
+          <a:schemeClr val="tx1"/>
+        </a:solidFill>
+        <a:latin typeface="+mn-lt"/>
+        <a:ea typeface="+mn-ea"/>
+        <a:cs typeface="+mn-cs"/>
+      </a:defRPr>
+    </a:lvl6pPr>
+    <a:lvl7pPr marL="2743200" algn="l" defTabSz="457200" rtl="0" eaLnBrk="1" latinLnBrk="0" hangingPunct="1">
+      <a:defRPr sz="1200" kern="1200">
+        <a:solidFill>
+          <a:schemeClr val="tx1"/>
+        </a:solidFill>
+        <a:latin typeface="+mn-lt"/>
+        <a:ea typeface="+mn-ea"/>
+        <a:cs typeface="+mn-cs"/>
+      </a:defRPr>
+    </a:lvl7pPr>
+    <a:lvl8pPr marL="3200400" algn="l" defTabSz="457200" rtl="0" eaLnBrk="1" latinLnBrk="0" hangingPunct="1">
+      <a:defRPr sz="1200" kern="1200">
+        <a:solidFill>
+          <a:schemeClr val="tx1"/>
+        </a:solidFill>
+        <a:latin typeface="+mn-lt"/>
+        <a:ea typeface="+mn-ea"/>
+        <a:cs typeface="+mn-cs"/>
+      </a:defRPr>
+    </a:lvl8pPr>
+    <a:lvl9pPr marL="3657600" algn="l" defTabSz="457200" rtl="0" eaLnBrk="1" latinLnBrk="0" hangingPunct="1">
+      <a:defRPr sz="1200" kern="1200">
+        <a:solidFill>
+          <a:schemeClr val="tx1"/>
+        </a:solidFill>
+        <a:latin typeface="+mn-lt"/>
+        <a:ea typeface="+mn-ea"/>
+        <a:cs typeface="+mn-cs"/>
+      </a:defRPr>
+    </a:lvl9pPr>
+  </p:notesStyle>
+</p:notesMaster>
+</file>
+
+<file path=ppt/notesSlides/notesSlide1.xml><?xml version="1.0" encoding="utf-8"?>
+<p:notes xmlns:a="http://schemas.openxmlformats.org/drawingml/2006/main" xmlns:p="http://schemas.openxmlformats.org/presentationml/2006/main" xmlns:r="http://schemas.openxmlformats.org/officeDocument/2006/relationships">
+  <p:cSld>
+    <p:spTree>
+      <p:nvGrpSpPr>
+        <p:cNvPr id="1" name=""/>
+        <p:cNvGrpSpPr/>
+        <p:nvPr/>
+      </p:nvGrpSpPr>
+      <p:grpSpPr>
+        <a:xfrm>
+          <a:off x="0" y="0"/>
+          <a:ext cx="0" cy="0"/>
+          <a:chOff x="0" y="0"/>
+          <a:chExt cx="0" cy="0"/>
+        </a:xfrm>
+      </p:grpSpPr>
+      <p:sp>
+        <p:nvSpPr>
+          <p:cNvPr id="2" name="Slide Image Placeholder 1"/>
+          <p:cNvSpPr>
+            <a:spLocks noGrp="1"/>
+          </p:cNvSpPr>
+          <p:nvPr>
+            <p:ph type="sldImg" idx="2"/>
+          </p:nvPr>
+        </p:nvSpPr>
+        <p:spPr/>
+      </p:sp>
+      <p:sp>
+        <p:nvSpPr>
+          <p:cNvPr id="3" name="Notes Placeholder 2"/>
+          <p:cNvSpPr>
+            <a:spLocks noGrp="1"/>
+          </p:cNvSpPr>
+          <p:nvPr>
+            <p:ph type="body" idx="3" sz="quarter"/>
+          </p:nvPr>
+        </p:nvSpPr>
+        <p:spPr/>
+        <p:txBody>
+          <a:bodyPr/>
+          <a:lstStyle/>
+          <a:p>
+            <a:r>
+              <a:t>Photo: IMG_4534.HEIC</a:t>
+            </a:r>
+          </a:p>
+          <a:p>
+            <a:r>
+              <a:t>Costa Rica Oct 2025, Armonía: laughing around the wire mesh bin with a thermometer</a:t>
+            </a:r>
+          </a:p>
+        </p:txBody>
+      </p:sp>
+      <p:sp>
+        <p:nvSpPr>
+          <p:cNvPr id="4" name="Slide Number Placeholder 3"/>
+          <p:cNvSpPr>
+            <a:spLocks noGrp="1"/>
+          </p:cNvSpPr>
+          <p:nvPr>
+            <p:ph type="sldNum" idx="5" sz="quarter"/>
+          </p:nvPr>
+        </p:nvSpPr>
+        <p:spPr/>
+      </p:sp>
+    </p:spTree>
+  </p:cSld>
+  <p:clrMapOvr>
+    <a:masterClrMapping/>
+  </p:clrMapOvr>
+</p:notes>
+</file>
+
+<file path=ppt/notesSlides/notesSlide2.xml><?xml version="1.0" encoding="utf-8"?>
+<p:notes xmlns:a="http://schemas.openxmlformats.org/drawingml/2006/main" xmlns:p="http://schemas.openxmlformats.org/presentationml/2006/main" xmlns:r="http://schemas.openxmlformats.org/officeDocument/2006/relationships">
+  <p:cSld>
+    <p:spTree>
+      <p:nvGrpSpPr>
+        <p:cNvPr id="1" name=""/>
+        <p:cNvGrpSpPr/>
+        <p:nvPr/>
+      </p:nvGrpSpPr>
+      <p:grpSpPr>
+        <a:xfrm>
+          <a:off x="0" y="0"/>
+          <a:ext cx="0" cy="0"/>
+          <a:chOff x="0" y="0"/>
+          <a:chExt cx="0" cy="0"/>
+        </a:xfrm>
+      </p:grpSpPr>
+      <p:sp>
+        <p:nvSpPr>
+          <p:cNvPr id="2" name="Slide Image Placeholder 1"/>
+          <p:cNvSpPr>
+            <a:spLocks noGrp="1"/>
+          </p:cNvSpPr>
+          <p:nvPr>
+            <p:ph type="sldImg" idx="2"/>
+          </p:nvPr>
+        </p:nvSpPr>
+        <p:spPr/>
+      </p:sp>
+      <p:sp>
+        <p:nvSpPr>
+          <p:cNvPr id="3" name="Notes Placeholder 2"/>
+          <p:cNvSpPr>
+            <a:spLocks noGrp="1"/>
+          </p:cNvSpPr>
+          <p:nvPr>
+            <p:ph type="body" idx="3" sz="quarter"/>
+          </p:nvPr>
+        </p:nvSpPr>
+        <p:spPr/>
+        <p:txBody>
+          <a:bodyPr/>
+          <a:lstStyle/>
+          <a:p>
+            <a:r>
+              <a:t>Photo: PXL_20251022_151710920.MP.jpg</a:t>
+            </a:r>
+          </a:p>
+          <a:p>
+            <a:r>
+              <a:t>Costa Rica Oct 2025, Armonía: wide view of the shed, several teams building at once</a:t>
+            </a:r>
+          </a:p>
+        </p:txBody>
+      </p:sp>
+      <p:sp>
+        <p:nvSpPr>
+          <p:cNvPr id="4" name="Slide Number Placeholder 3"/>
+          <p:cNvSpPr>
+            <a:spLocks noGrp="1"/>
+          </p:cNvSpPr>
+          <p:nvPr>
+            <p:ph type="sldNum" idx="5" sz="quarter"/>
+          </p:nvPr>
+        </p:nvSpPr>
+        <p:spPr/>
+      </p:sp>
+    </p:spTree>
+  </p:cSld>
+  <p:clrMapOvr>
+    <a:masterClrMapping/>
+  </p:clrMapOvr>
+</p:notes>
+</file>
+
+<file path=ppt/notesSlides/notesSlide3.xml><?xml version="1.0" encoding="utf-8"?>
+<p:notes xmlns:a="http://schemas.openxmlformats.org/drawingml/2006/main" xmlns:p="http://schemas.openxmlformats.org/presentationml/2006/main" xmlns:r="http://schemas.openxmlformats.org/officeDocument/2006/relationships">
+  <p:cSld>
+    <p:spTree>
+      <p:nvGrpSpPr>
+        <p:cNvPr id="1" name=""/>
+        <p:cNvGrpSpPr/>
+        <p:nvPr/>
+      </p:nvGrpSpPr>
+      <p:grpSpPr>
+        <a:xfrm>
+          <a:off x="0" y="0"/>
+          <a:ext cx="0" cy="0"/>
+          <a:chOff x="0" y="0"/>
+          <a:chExt cx="0" cy="0"/>
+        </a:xfrm>
+      </p:grpSpPr>
+      <p:sp>
+        <p:nvSpPr>
+          <p:cNvPr id="2" name="Slide Image Placeholder 1"/>
+          <p:cNvSpPr>
+            <a:spLocks noGrp="1"/>
+          </p:cNvSpPr>
+          <p:nvPr>
+            <p:ph type="sldImg" idx="2"/>
+          </p:nvPr>
+        </p:nvSpPr>
+        <p:spPr/>
+      </p:sp>
+      <p:sp>
+        <p:nvSpPr>
+          <p:cNvPr id="3" name="Notes Placeholder 2"/>
+          <p:cNvSpPr>
+            <a:spLocks noGrp="1"/>
+          </p:cNvSpPr>
+          <p:nvPr>
+            <p:ph type="body" idx="3" sz="quarter"/>
+          </p:nvPr>
+        </p:nvSpPr>
+        <p:spPr/>
+        <p:txBody>
+          <a:bodyPr/>
+          <a:lstStyle/>
+          <a:p>
+            <a:r>
+              <a:t>Photo: PXL_20240716_224324982_HandsInSoil.jpg</a:t>
+            </a:r>
+          </a:p>
+          <a:p>
+            <a:r>
+              <a:t>Costa Rica Jul 2024, Armonía: hands in woody compost (HandsInSoil)</a:t>
+            </a:r>
+          </a:p>
+        </p:txBody>
+      </p:sp>
+      <p:sp>
+        <p:nvSpPr>
+          <p:cNvPr id="4" name="Slide Number Placeholder 3"/>
+          <p:cNvSpPr>
+            <a:spLocks noGrp="1"/>
+          </p:cNvSpPr>
+          <p:nvPr>
+            <p:ph type="sldNum" idx="5" sz="quarter"/>
+          </p:nvPr>
+        </p:nvSpPr>
+        <p:spPr/>
+      </p:sp>
+    </p:spTree>
+  </p:cSld>
+  <p:clrMapOvr>
+    <a:masterClrMapping/>
+  </p:clrMapOvr>
+</p:notes>
+</file>
+
+<file path=ppt/notesSlides/notesSlide4.xml><?xml version="1.0" encoding="utf-8"?>
+<p:notes xmlns:a="http://schemas.openxmlformats.org/drawingml/2006/main" xmlns:p="http://schemas.openxmlformats.org/presentationml/2006/main" xmlns:r="http://schemas.openxmlformats.org/officeDocument/2006/relationships">
+  <p:cSld>
+    <p:spTree>
+      <p:nvGrpSpPr>
+        <p:cNvPr id="1" name=""/>
+        <p:cNvGrpSpPr/>
+        <p:nvPr/>
+      </p:nvGrpSpPr>
+      <p:grpSpPr>
+        <a:xfrm>
+          <a:off x="0" y="0"/>
+          <a:ext cx="0" cy="0"/>
+          <a:chOff x="0" y="0"/>
+          <a:chExt cx="0" cy="0"/>
+        </a:xfrm>
+      </p:grpSpPr>
+      <p:sp>
+        <p:nvSpPr>
+          <p:cNvPr id="2" name="Slide Image Placeholder 1"/>
+          <p:cNvSpPr>
+            <a:spLocks noGrp="1"/>
+          </p:cNvSpPr>
+          <p:nvPr>
+            <p:ph type="sldImg" idx="2"/>
+          </p:nvPr>
+        </p:nvSpPr>
+        <p:spPr/>
+      </p:sp>
+      <p:sp>
+        <p:nvSpPr>
+          <p:cNvPr id="3" name="Notes Placeholder 2"/>
+          <p:cNvSpPr>
+            <a:spLocks noGrp="1"/>
+          </p:cNvSpPr>
+          <p:nvPr>
+            <p:ph type="body" idx="3" sz="quarter"/>
+          </p:nvPr>
+        </p:nvSpPr>
+        <p:spPr/>
+        <p:txBody>
+          <a:bodyPr/>
+          <a:lstStyle/>
+          <a:p>
+            <a:r>
+              <a:t>Photo: PXL_20251020_222404850.jpg + Compost_Tea_Prep.jpg</a:t>
+            </a:r>
+          </a:p>
+          <a:p>
+            <a:r>
+              <a:t>Costa Rica Oct 2025: frothy brew in the blue tub (top); Costa Rica Jul 2024: Compost Tea Prep bucket brewer (bottom)</a:t>
+            </a:r>
+          </a:p>
+        </p:txBody>
+      </p:sp>
+      <p:sp>
+        <p:nvSpPr>
+          <p:cNvPr id="4" name="Slide Number Placeholder 3"/>
+          <p:cNvSpPr>
+            <a:spLocks noGrp="1"/>
+          </p:cNvSpPr>
+          <p:nvPr>
+            <p:ph type="sldNum" idx="5" sz="quarter"/>
+          </p:nvPr>
+        </p:nvSpPr>
+        <p:spPr/>
+      </p:sp>
+    </p:spTree>
+  </p:cSld>
+  <p:clrMapOvr>
+    <a:masterClrMapping/>
+  </p:clrMapOvr>
+</p:notes>
+</file>
+
+<file path=ppt/notesSlides/notesSlide5.xml><?xml version="1.0" encoding="utf-8"?>
+<p:notes xmlns:a="http://schemas.openxmlformats.org/drawingml/2006/main" xmlns:p="http://schemas.openxmlformats.org/presentationml/2006/main" xmlns:r="http://schemas.openxmlformats.org/officeDocument/2006/relationships">
+  <p:cSld>
+    <p:spTree>
+      <p:nvGrpSpPr>
+        <p:cNvPr id="1" name=""/>
+        <p:cNvGrpSpPr/>
+        <p:nvPr/>
+      </p:nvGrpSpPr>
+      <p:grpSpPr>
+        <a:xfrm>
+          <a:off x="0" y="0"/>
+          <a:ext cx="0" cy="0"/>
+          <a:chOff x="0" y="0"/>
+          <a:chExt cx="0" cy="0"/>
+        </a:xfrm>
+      </p:grpSpPr>
+      <p:sp>
+        <p:nvSpPr>
+          <p:cNvPr id="2" name="Slide Image Placeholder 1"/>
+          <p:cNvSpPr>
+            <a:spLocks noGrp="1"/>
+          </p:cNvSpPr>
+          <p:nvPr>
+            <p:ph type="sldImg" idx="2"/>
+          </p:nvPr>
+        </p:nvSpPr>
+        <p:spPr/>
+      </p:sp>
+      <p:sp>
+        <p:nvSpPr>
+          <p:cNvPr id="3" name="Notes Placeholder 2"/>
+          <p:cNvSpPr>
+            <a:spLocks noGrp="1"/>
+          </p:cNvSpPr>
+          <p:nvPr>
+            <p:ph type="body" idx="3" sz="quarter"/>
+          </p:nvPr>
+        </p:nvSpPr>
+        <p:spPr/>
+        <p:txBody>
+          <a:bodyPr/>
+          <a:lstStyle/>
+          <a:p>
+            <a:r>
+              <a:t>Photo: PXL_20251023_191907277.jpg</a:t>
+            </a:r>
+          </a:p>
+          <a:p>
+            <a:r>
+              <a:t>Costa Rica Oct 2025, Armonía: class watching live microscopy on screen (Drive ID 1YTuACdcqtVqv99HAArkRDlBUYdnCP8KZ), brightened</a:t>
+            </a:r>
+          </a:p>
+        </p:txBody>
+      </p:sp>
+      <p:sp>
+        <p:nvSpPr>
+          <p:cNvPr id="4" name="Slide Number Placeholder 3"/>
+          <p:cNvSpPr>
+            <a:spLocks noGrp="1"/>
+          </p:cNvSpPr>
+          <p:nvPr>
+            <p:ph type="sldNum" idx="5" sz="quarter"/>
+          </p:nvPr>
+        </p:nvSpPr>
+        <p:spPr/>
+      </p:sp>
+    </p:spTree>
+  </p:cSld>
+  <p:clrMapOvr>
+    <a:masterClrMapping/>
+  </p:clrMapOvr>
+</p:notes>
+</file>
+
+<file path=ppt/notesSlides/notesSlide6.xml><?xml version="1.0" encoding="utf-8"?>
+<p:notes xmlns:a="http://schemas.openxmlformats.org/drawingml/2006/main" xmlns:p="http://schemas.openxmlformats.org/presentationml/2006/main" xmlns:r="http://schemas.openxmlformats.org/officeDocument/2006/relationships">
+  <p:cSld>
+    <p:spTree>
+      <p:nvGrpSpPr>
+        <p:cNvPr id="1" name=""/>
+        <p:cNvGrpSpPr/>
+        <p:nvPr/>
+      </p:nvGrpSpPr>
+      <p:grpSpPr>
+        <a:xfrm>
+          <a:off x="0" y="0"/>
+          <a:ext cx="0" cy="0"/>
+          <a:chOff x="0" y="0"/>
+          <a:chExt cx="0" cy="0"/>
+        </a:xfrm>
+      </p:grpSpPr>
+      <p:sp>
+        <p:nvSpPr>
+          <p:cNvPr id="2" name="Slide Image Placeholder 1"/>
+          <p:cNvSpPr>
+            <a:spLocks noGrp="1"/>
+          </p:cNvSpPr>
+          <p:nvPr>
+            <p:ph type="sldImg" idx="2"/>
+          </p:nvPr>
+        </p:nvSpPr>
+        <p:spPr/>
+      </p:sp>
+      <p:sp>
+        <p:nvSpPr>
+          <p:cNvPr id="3" name="Notes Placeholder 2"/>
+          <p:cNvSpPr>
+            <a:spLocks noGrp="1"/>
+          </p:cNvSpPr>
+          <p:nvPr>
+            <p:ph type="body" idx="3" sz="quarter"/>
+          </p:nvPr>
+        </p:nvSpPr>
+        <p:spPr/>
+        <p:txBody>
+          <a:bodyPr/>
+          <a:lstStyle/>
+          <a:p>
+            <a:r>
+              <a:t>Photo: PXL_20251022_172210012.jpg</a:t>
+            </a:r>
+          </a:p>
+          <a:p>
+            <a:r>
+              <a:t>Costa Rica Oct 2025, Armonía: the class under the big tree in the forest</a:t>
+            </a:r>
+          </a:p>
+        </p:txBody>
+      </p:sp>
+      <p:sp>
+        <p:nvSpPr>
+          <p:cNvPr id="4" name="Slide Number Placeholder 3"/>
+          <p:cNvSpPr>
+            <a:spLocks noGrp="1"/>
+          </p:cNvSpPr>
+          <p:nvPr>
+            <p:ph type="sldNum" idx="5" sz="quarter"/>
+          </p:nvPr>
+        </p:nvSpPr>
+        <p:spPr/>
+      </p:sp>
+    </p:spTree>
+  </p:cSld>
+  <p:clrMapOvr>
+    <a:masterClrMapping/>
+  </p:clrMapOvr>
+</p:notes>
 </file>
 
 <file path=ppt/slideLayouts/slideLayout1.xml><?xml version="1.0" encoding="utf-8"?>
@@ -3084,14 +3886,6 @@
 <file path=ppt/slides/slide1.xml><?xml version="1.0" encoding="utf-8"?>
 <p:sld xmlns:a="http://schemas.openxmlformats.org/drawingml/2006/main" xmlns:p="http://schemas.openxmlformats.org/presentationml/2006/main" xmlns:r="http://schemas.openxmlformats.org/officeDocument/2006/relationships">
   <p:cSld>
-    <p:bg>
-      <p:bgPr>
-        <a:solidFill>
-          <a:srgbClr val="22371F"/>
-        </a:solidFill>
-        <a:effectLst/>
-      </p:bgPr>
-    </p:bg>
     <p:spTree>
       <p:nvGrpSpPr>
         <p:cNvPr id="1" name=""/>
@@ -3101,153 +3895,7 @@
       <p:grpSpPr/>
       <p:pic>
         <p:nvPicPr>
-          <p:cNvPr id="2" name="Picture 1" descr="_s03-11-2026-costa-rica-early-bird1_0.jpg"/>
-          <p:cNvPicPr>
-            <a:picLocks noChangeAspect="1"/>
-          </p:cNvPicPr>
-          <p:nvPr/>
-        </p:nvPicPr>
-        <p:blipFill>
-          <a:blip r:embed="rId2"/>
-          <a:stretch>
-            <a:fillRect/>
-          </a:stretch>
-        </p:blipFill>
-        <p:spPr>
-          <a:xfrm>
-            <a:off x="0" y="0"/>
-            <a:ext cx="10287000" cy="7620000"/>
-          </a:xfrm>
-          <a:prstGeom prst="rect">
-            <a:avLst/>
-          </a:prstGeom>
-        </p:spPr>
-      </p:pic>
-      <p:sp>
-        <p:nvSpPr>
-          <p:cNvPr id="3" name="Rectangle 2"/>
-          <p:cNvSpPr/>
-          <p:nvPr/>
-        </p:nvSpPr>
-        <p:spPr>
-          <a:xfrm>
-            <a:off x="0" y="7048500"/>
-            <a:ext cx="10287000" cy="5810250"/>
-          </a:xfrm>
-          <a:prstGeom prst="rect">
-            <a:avLst/>
-          </a:prstGeom>
-          <a:solidFill>
-            <a:srgbClr val="22371F"/>
-          </a:solidFill>
-          <a:ln>
-            <a:noFill/>
-          </a:ln>
-          <a:effectLst/>
-        </p:spPr>
-        <p:style>
-          <a:lnRef idx="1">
-            <a:schemeClr val="accent1"/>
-          </a:lnRef>
-          <a:fillRef idx="3">
-            <a:schemeClr val="accent1"/>
-          </a:fillRef>
-          <a:effectRef idx="2">
-            <a:schemeClr val="accent1"/>
-          </a:effectRef>
-          <a:fontRef idx="minor">
-            <a:schemeClr val="lt1"/>
-          </a:fontRef>
-        </p:style>
-        <p:txBody>
-          <a:bodyPr rtlCol="0" anchor="ctr"/>
-          <a:lstStyle/>
-          <a:p>
-            <a:pPr algn="ctr"/>
-          </a:p>
-        </p:txBody>
-      </p:sp>
-      <p:sp>
-        <p:nvSpPr>
-          <p:cNvPr id="4" name="TextBox 3"/>
-          <p:cNvSpPr txBox="1"/>
-          <p:nvPr/>
-        </p:nvSpPr>
-        <p:spPr>
-          <a:xfrm>
-            <a:off x="685800" y="7620000"/>
-            <a:ext cx="7772400" cy="1905762"/>
-          </a:xfrm>
-          <a:prstGeom prst="rect">
-            <a:avLst/>
-          </a:prstGeom>
-          <a:noFill/>
-        </p:spPr>
-        <p:txBody>
-          <a:bodyPr wrap="square" lIns="0" rIns="0" tIns="0" bIns="0" anchor="t">
-            <a:spAutoFit/>
-          </a:bodyPr>
-          <a:lstStyle/>
-          <a:p>
-            <a:pPr algn="l">
-              <a:lnSpc>
-                <a:spcPct val="88560"/>
-              </a:lnSpc>
-            </a:pPr>
-            <a:r>
-              <a:rPr sz="6600" b="0">
-                <a:solidFill>
-                  <a:srgbClr val="F4F1EA"/>
-                </a:solidFill>
-                <a:latin typeface="Fredoka"/>
-              </a:rPr>
-              <a:t>The early bird ends tomorrow.</a:t>
-            </a:r>
-          </a:p>
-        </p:txBody>
-      </p:sp>
-      <p:sp>
-        <p:nvSpPr>
-          <p:cNvPr id="5" name="TextBox 4"/>
-          <p:cNvSpPr txBox="1"/>
-          <p:nvPr/>
-        </p:nvSpPr>
-        <p:spPr>
-          <a:xfrm>
-            <a:off x="685800" y="9754362"/>
-            <a:ext cx="7772400" cy="948690"/>
-          </a:xfrm>
-          <a:prstGeom prst="rect">
-            <a:avLst/>
-          </a:prstGeom>
-          <a:noFill/>
-        </p:spPr>
-        <p:txBody>
-          <a:bodyPr wrap="square" lIns="0" rIns="0" tIns="0" bIns="0" anchor="t">
-            <a:spAutoFit/>
-          </a:bodyPr>
-          <a:lstStyle/>
-          <a:p>
-            <a:pPr algn="l">
-              <a:lnSpc>
-                <a:spcPct val="114800"/>
-              </a:lnSpc>
-            </a:pPr>
-            <a:r>
-              <a:rPr sz="2400" b="1">
-                <a:solidFill>
-                  <a:srgbClr val="DDE5D4"/>
-                </a:solidFill>
-                <a:latin typeface="Montserrat"/>
-              </a:rPr>
-              <a:t>Accelerator Workshop, Costa Rica · 18 to 29 January 2027</a:t>
-            </a:r>
-          </a:p>
-        </p:txBody>
-      </p:sp>
-      <p:pic>
-        <p:nvPicPr>
-          <p:cNvPr id="6" name="Picture 5" descr="heliconia-sh.png"/>
+          <p:cNvPr id="2" name="photo IMG_4534" descr="image.jpg"/>
           <p:cNvPicPr>
             <a:picLocks noChangeAspect="1"/>
           </p:cNvPicPr>
@@ -3261,98 +3909,24 @@
         </p:blipFill>
         <p:spPr>
           <a:xfrm>
-            <a:off x="8382000" y="4000500"/>
-            <a:ext cx="1866900" cy="4000500"/>
+            <a:off x="0" y="0"/>
+            <a:ext cx="10287000" cy="12858750"/>
           </a:xfrm>
           <a:prstGeom prst="rect">
             <a:avLst/>
           </a:prstGeom>
         </p:spPr>
       </p:pic>
-      <p:pic>
-        <p:nvPicPr>
-          <p:cNvPr id="7" name="Picture 6" descr="logo-disc.png"/>
-          <p:cNvPicPr>
-            <a:picLocks noChangeAspect="1"/>
-          </p:cNvPicPr>
+      <p:sp>
+        <p:nvSpPr>
+          <p:cNvPr id="3" name="green band (continues into slide 2)"/>
+          <p:cNvSpPr/>
           <p:nvPr/>
-        </p:nvPicPr>
-        <p:blipFill>
-          <a:blip r:embed="rId4"/>
-          <a:stretch>
-            <a:fillRect/>
-          </a:stretch>
-        </p:blipFill>
+        </p:nvSpPr>
         <p:spPr>
           <a:xfrm>
-            <a:off x="8362950" y="10934700"/>
-            <a:ext cx="1238250" cy="1238250"/>
-          </a:xfrm>
-          <a:prstGeom prst="rect">
-            <a:avLst/>
-          </a:prstGeom>
-        </p:spPr>
-      </p:pic>
-    </p:spTree>
-  </p:cSld>
-  <p:clrMapOvr>
-    <a:masterClrMapping/>
-  </p:clrMapOvr>
-</p:sld>
-</file>
-
-<file path=ppt/slides/slide2.xml><?xml version="1.0" encoding="utf-8"?>
-<p:sld xmlns:a="http://schemas.openxmlformats.org/drawingml/2006/main" xmlns:p="http://schemas.openxmlformats.org/presentationml/2006/main" xmlns:r="http://schemas.openxmlformats.org/officeDocument/2006/relationships">
-  <p:cSld>
-    <p:bg>
-      <p:bgPr>
-        <a:solidFill>
-          <a:srgbClr val="F4F1EA"/>
-        </a:solidFill>
-        <a:effectLst/>
-      </p:bgPr>
-    </p:bg>
-    <p:spTree>
-      <p:nvGrpSpPr>
-        <p:cNvPr id="1" name=""/>
-        <p:cNvGrpSpPr/>
-        <p:nvPr/>
-      </p:nvGrpSpPr>
-      <p:grpSpPr/>
-      <p:pic>
-        <p:nvPicPr>
-          <p:cNvPr id="2" name="Picture 1" descr="_s03-11-2026-costa-rica-early-bird2_0.jpg"/>
-          <p:cNvPicPr>
-            <a:picLocks noChangeAspect="1"/>
-          </p:cNvPicPr>
-          <p:nvPr/>
-        </p:nvPicPr>
-        <p:blipFill>
-          <a:blip r:embed="rId2"/>
-          <a:stretch>
-            <a:fillRect/>
-          </a:stretch>
-        </p:blipFill>
-        <p:spPr>
-          <a:xfrm>
-            <a:off x="0" y="0"/>
-            <a:ext cx="10287000" cy="8191500"/>
-          </a:xfrm>
-          <a:prstGeom prst="rect">
-            <a:avLst/>
-          </a:prstGeom>
-        </p:spPr>
-      </p:pic>
-      <p:sp>
-        <p:nvSpPr>
-          <p:cNvPr id="3" name="Rectangle 2"/>
-          <p:cNvSpPr/>
-          <p:nvPr/>
-        </p:nvSpPr>
-        <p:spPr>
-          <a:xfrm>
-            <a:off x="685800" y="6667500"/>
-            <a:ext cx="8915400" cy="4095750"/>
+            <a:off x="571500" y="7905750"/>
+            <a:ext cx="9715500" cy="3810000"/>
           </a:xfrm>
           <a:prstGeom prst="rect">
             <a:avLst/>
@@ -3389,14 +3963,14 @@
       </p:sp>
       <p:sp>
         <p:nvSpPr>
-          <p:cNvPr id="4" name="TextBox 3"/>
+          <p:cNvPr id="4" name="headline"/>
           <p:cNvSpPr txBox="1"/>
           <p:nvPr/>
         </p:nvSpPr>
         <p:spPr>
           <a:xfrm>
-            <a:off x="1162050" y="7143750"/>
-            <a:ext cx="6724650" cy="1535430"/>
+            <a:off x="1047750" y="8286750"/>
+            <a:ext cx="8858250" cy="1905000"/>
           </a:xfrm>
           <a:prstGeom prst="rect">
             <a:avLst/>
@@ -3411,31 +3985,31 @@
           <a:p>
             <a:pPr algn="l">
               <a:lnSpc>
-                <a:spcPct val="88560"/>
+                <a:spcPct val="105000"/>
               </a:lnSpc>
             </a:pPr>
             <a:r>
-              <a:rPr sz="5250" b="0">
+              <a:rPr sz="4800" b="1">
                 <a:solidFill>
                   <a:srgbClr val="F4F1EA"/>
                 </a:solidFill>
-                <a:latin typeface="Fredoka"/>
+                <a:latin typeface="Montserrat"/>
               </a:rPr>
-              <a:t>A year of hands-on experience in 10 days.</a:t>
-            </a:r>
-          </a:p>
-        </p:txBody>
-      </p:sp>
-      <p:sp>
-        <p:nvSpPr>
-          <p:cNvPr id="5" name="TextBox 4"/>
+              <a:t>Early Nematode Discount ends tomorrow</a:t>
+            </a:r>
+          </a:p>
+        </p:txBody>
+      </p:sp>
+      <p:sp>
+        <p:nvSpPr>
+          <p:cNvPr id="5" name="small line"/>
           <p:cNvSpPr txBox="1"/>
           <p:nvPr/>
         </p:nvSpPr>
         <p:spPr>
           <a:xfrm>
-            <a:off x="1162050" y="8907780"/>
-            <a:ext cx="6724650" cy="1375409"/>
+            <a:off x="1066800" y="10953750"/>
+            <a:ext cx="8572500" cy="476250"/>
           </a:xfrm>
           <a:prstGeom prst="rect">
             <a:avLst/>
@@ -3450,24 +4024,42 @@
           <a:p>
             <a:pPr algn="l">
               <a:lnSpc>
-                <a:spcPct val="114800"/>
+                <a:spcPct val="105000"/>
               </a:lnSpc>
             </a:pPr>
             <a:r>
-              <a:rPr sz="2400" b="0">
+              <a:rPr sz="2850" b="0">
                 <a:solidFill>
-                  <a:srgbClr val="DDE5D4"/>
+                  <a:srgbClr val="F4F1EA"/>
                 </a:solidFill>
-                <a:latin typeface="Montserrat"/>
+                <a:latin typeface="Source Sans 3"/>
               </a:rPr>
-              <a:t>What takes 18 to 24 months alone, you do here in two weeks, with mentors beside you.</a:t>
-            </a:r>
-          </a:p>
-        </p:txBody>
-      </p:sp>
+              <a:t>Accelerator Workshop · Costa Rica</a:t>
+            </a:r>
+          </a:p>
+        </p:txBody>
+      </p:sp>
+    </p:spTree>
+  </p:cSld>
+  <p:clrMapOvr>
+    <a:masterClrMapping/>
+  </p:clrMapOvr>
+</p:sld>
+</file>
+
+<file path=ppt/slides/slide2.xml><?xml version="1.0" encoding="utf-8"?>
+<p:sld xmlns:a="http://schemas.openxmlformats.org/drawingml/2006/main" xmlns:p="http://schemas.openxmlformats.org/presentationml/2006/main" xmlns:r="http://schemas.openxmlformats.org/officeDocument/2006/relationships">
+  <p:cSld>
+    <p:spTree>
+      <p:nvGrpSpPr>
+        <p:cNvPr id="1" name=""/>
+        <p:cNvGrpSpPr/>
+        <p:nvPr/>
+      </p:nvGrpSpPr>
+      <p:grpSpPr/>
       <p:pic>
         <p:nvPicPr>
-          <p:cNvPr id="6" name="Picture 5" descr="torch-ginger-sh.png"/>
+          <p:cNvPr id="2" name="photo PXL_20251022_151710920" descr="image.jpg"/>
           <p:cNvPicPr>
             <a:picLocks noChangeAspect="1"/>
           </p:cNvPicPr>
@@ -3481,382 +4073,30 @@
         </p:blipFill>
         <p:spPr>
           <a:xfrm>
-            <a:off x="8477250" y="3810000"/>
-            <a:ext cx="2381250" cy="3810000"/>
+            <a:off x="3810000" y="0"/>
+            <a:ext cx="6477000" cy="12858750"/>
           </a:xfrm>
           <a:prstGeom prst="rect">
             <a:avLst/>
           </a:prstGeom>
         </p:spPr>
       </p:pic>
-      <p:pic>
-        <p:nvPicPr>
-          <p:cNvPr id="7" name="Picture 6" descr="logo.png"/>
-          <p:cNvPicPr>
-            <a:picLocks noChangeAspect="1"/>
-          </p:cNvPicPr>
+      <p:sp>
+        <p:nvSpPr>
+          <p:cNvPr id="3" name="green band (continues into slide 2)"/>
+          <p:cNvSpPr/>
           <p:nvPr/>
-        </p:nvPicPr>
-        <p:blipFill>
-          <a:blip r:embed="rId4"/>
-          <a:stretch>
-            <a:fillRect/>
-          </a:stretch>
-        </p:blipFill>
+        </p:nvSpPr>
         <p:spPr>
           <a:xfrm>
-            <a:off x="8458200" y="11029950"/>
-            <a:ext cx="1143000" cy="990600"/>
-          </a:xfrm>
-          <a:prstGeom prst="rect">
-            <a:avLst/>
-          </a:prstGeom>
-        </p:spPr>
-      </p:pic>
-    </p:spTree>
-  </p:cSld>
-  <p:clrMapOvr>
-    <a:masterClrMapping/>
-  </p:clrMapOvr>
-</p:sld>
-</file>
-
-<file path=ppt/slides/slide3.xml><?xml version="1.0" encoding="utf-8"?>
-<p:sld xmlns:a="http://schemas.openxmlformats.org/drawingml/2006/main" xmlns:p="http://schemas.openxmlformats.org/presentationml/2006/main" xmlns:r="http://schemas.openxmlformats.org/officeDocument/2006/relationships">
-  <p:cSld>
-    <p:bg>
-      <p:bgPr>
-        <a:solidFill>
-          <a:srgbClr val="F4F1EA"/>
-        </a:solidFill>
-        <a:effectLst/>
-      </p:bgPr>
-    </p:bg>
-    <p:spTree>
-      <p:nvGrpSpPr>
-        <p:cNvPr id="1" name=""/>
-        <p:cNvGrpSpPr/>
-        <p:nvPr/>
-      </p:nvGrpSpPr>
-      <p:grpSpPr/>
-      <p:pic>
-        <p:nvPicPr>
-          <p:cNvPr id="2" name="Picture 1" descr="_s03-11-2026-costa-rica-early-bird3_0.jpg"/>
-          <p:cNvPicPr>
-            <a:picLocks noChangeAspect="1"/>
-          </p:cNvPicPr>
-          <p:nvPr/>
-        </p:nvPicPr>
-        <p:blipFill>
-          <a:blip r:embed="rId2"/>
-          <a:stretch>
-            <a:fillRect/>
-          </a:stretch>
-        </p:blipFill>
-        <p:spPr>
-          <a:xfrm>
-            <a:off x="0" y="0"/>
-            <a:ext cx="5143500" cy="7810500"/>
-          </a:xfrm>
-          <a:prstGeom prst="rect">
-            <a:avLst/>
-          </a:prstGeom>
-        </p:spPr>
-      </p:pic>
-      <p:pic>
-        <p:nvPicPr>
-          <p:cNvPr id="3" name="Picture 2" descr="_s03-11-2026-costa-rica-early-bird3_1.jpg"/>
-          <p:cNvPicPr>
-            <a:picLocks noChangeAspect="1"/>
-          </p:cNvPicPr>
-          <p:nvPr/>
-        </p:nvPicPr>
-        <p:blipFill>
-          <a:blip r:embed="rId3"/>
-          <a:stretch>
-            <a:fillRect/>
-          </a:stretch>
-        </p:blipFill>
-        <p:spPr>
-          <a:xfrm>
-            <a:off x="5143500" y="0"/>
-            <a:ext cx="5143500" cy="7810500"/>
-          </a:xfrm>
-          <a:prstGeom prst="rect">
-            <a:avLst/>
-          </a:prstGeom>
-        </p:spPr>
-      </p:pic>
-      <p:sp>
-        <p:nvSpPr>
-          <p:cNvPr id="4" name="TextBox 3"/>
-          <p:cNvSpPr txBox="1"/>
-          <p:nvPr/>
-        </p:nvSpPr>
-        <p:spPr>
-          <a:xfrm>
-            <a:off x="685800" y="8382000"/>
-            <a:ext cx="4000500" cy="495300"/>
-          </a:xfrm>
-          <a:prstGeom prst="rect">
-            <a:avLst/>
-          </a:prstGeom>
-          <a:noFill/>
-        </p:spPr>
-        <p:txBody>
-          <a:bodyPr wrap="square" lIns="0" rIns="0" tIns="0" bIns="0" anchor="t">
-            <a:spAutoFit/>
-          </a:bodyPr>
-          <a:lstStyle/>
-          <a:p>
-            <a:pPr algn="l">
-              <a:lnSpc>
-                <a:spcPct val="114800"/>
-              </a:lnSpc>
-            </a:pPr>
-            <a:r>
-              <a:rPr sz="2250" b="1">
-                <a:solidFill>
-                  <a:srgbClr val="156826"/>
-                </a:solidFill>
-                <a:latin typeface="Montserrat"/>
-              </a:rPr>
-              <a:t>WEEK ONE</a:t>
-            </a:r>
-          </a:p>
-        </p:txBody>
-      </p:sp>
-      <p:sp>
-        <p:nvSpPr>
-          <p:cNvPr id="5" name="TextBox 4"/>
-          <p:cNvSpPr txBox="1"/>
-          <p:nvPr/>
-        </p:nvSpPr>
-        <p:spPr>
-          <a:xfrm>
-            <a:off x="685800" y="8810625"/>
-            <a:ext cx="4191000" cy="877062"/>
-          </a:xfrm>
-          <a:prstGeom prst="rect">
-            <a:avLst/>
-          </a:prstGeom>
-          <a:noFill/>
-        </p:spPr>
-        <p:txBody>
-          <a:bodyPr wrap="square" lIns="0" rIns="0" tIns="0" bIns="0" anchor="t">
-            <a:spAutoFit/>
-          </a:bodyPr>
-          <a:lstStyle/>
-          <a:p>
-            <a:pPr algn="l">
-              <a:lnSpc>
-                <a:spcPct val="88560"/>
-              </a:lnSpc>
-            </a:pPr>
-            <a:r>
-              <a:rPr sz="5700" b="0">
-                <a:solidFill>
-                  <a:srgbClr val="4F3433"/>
-                </a:solidFill>
-                <a:latin typeface="Fredoka"/>
-              </a:rPr>
-              <a:t>Compost</a:t>
-            </a:r>
-          </a:p>
-        </p:txBody>
-      </p:sp>
-      <p:sp>
-        <p:nvSpPr>
-          <p:cNvPr id="6" name="TextBox 5"/>
-          <p:cNvSpPr txBox="1"/>
-          <p:nvPr/>
-        </p:nvSpPr>
-        <p:spPr>
-          <a:xfrm>
-            <a:off x="5429250" y="8382000"/>
-            <a:ext cx="4191000" cy="495300"/>
-          </a:xfrm>
-          <a:prstGeom prst="rect">
-            <a:avLst/>
-          </a:prstGeom>
-          <a:noFill/>
-        </p:spPr>
-        <p:txBody>
-          <a:bodyPr wrap="square" lIns="0" rIns="0" tIns="0" bIns="0" anchor="t">
-            <a:spAutoFit/>
-          </a:bodyPr>
-          <a:lstStyle/>
-          <a:p>
-            <a:pPr algn="l">
-              <a:lnSpc>
-                <a:spcPct val="114800"/>
-              </a:lnSpc>
-            </a:pPr>
-            <a:r>
-              <a:rPr sz="2250" b="1">
-                <a:solidFill>
-                  <a:srgbClr val="156826"/>
-                </a:solidFill>
-                <a:latin typeface="Montserrat"/>
-              </a:rPr>
-              <a:t>WEEK TWO</a:t>
-            </a:r>
-          </a:p>
-        </p:txBody>
-      </p:sp>
-      <p:sp>
-        <p:nvSpPr>
-          <p:cNvPr id="7" name="TextBox 6"/>
-          <p:cNvSpPr txBox="1"/>
-          <p:nvPr/>
-        </p:nvSpPr>
-        <p:spPr>
-          <a:xfrm>
-            <a:off x="5429250" y="8810625"/>
-            <a:ext cx="4191000" cy="1658874"/>
-          </a:xfrm>
-          <a:prstGeom prst="rect">
-            <a:avLst/>
-          </a:prstGeom>
-          <a:noFill/>
-        </p:spPr>
-        <p:txBody>
-          <a:bodyPr wrap="square" lIns="0" rIns="0" tIns="0" bIns="0" anchor="t">
-            <a:spAutoFit/>
-          </a:bodyPr>
-          <a:lstStyle/>
-          <a:p>
-            <a:pPr algn="l">
-              <a:lnSpc>
-                <a:spcPct val="88560"/>
-              </a:lnSpc>
-            </a:pPr>
-            <a:r>
-              <a:rPr sz="5700" b="0">
-                <a:solidFill>
-                  <a:srgbClr val="4F3433"/>
-                </a:solidFill>
-                <a:latin typeface="Fredoka"/>
-              </a:rPr>
-              <a:t>Liquid amendments</a:t>
-            </a:r>
-          </a:p>
-        </p:txBody>
-      </p:sp>
-      <p:pic>
-        <p:nvPicPr>
-          <p:cNvPr id="8" name="Picture 7" descr="poro-flower-sh.png"/>
-          <p:cNvPicPr>
-            <a:picLocks noChangeAspect="1"/>
-          </p:cNvPicPr>
-          <p:nvPr/>
-        </p:nvPicPr>
-        <p:blipFill>
-          <a:blip r:embed="rId4"/>
-          <a:stretch>
-            <a:fillRect/>
-          </a:stretch>
-        </p:blipFill>
-        <p:spPr>
-          <a:xfrm>
-            <a:off x="-381000" y="10953750"/>
-            <a:ext cx="2571750" cy="2095500"/>
-          </a:xfrm>
-          <a:prstGeom prst="rect">
-            <a:avLst/>
-          </a:prstGeom>
-        </p:spPr>
-      </p:pic>
-      <p:pic>
-        <p:nvPicPr>
-          <p:cNvPr id="9" name="Picture 8" descr="logo.png"/>
-          <p:cNvPicPr>
-            <a:picLocks noChangeAspect="1"/>
-          </p:cNvPicPr>
-          <p:nvPr/>
-        </p:nvPicPr>
-        <p:blipFill>
-          <a:blip r:embed="rId5"/>
-          <a:stretch>
-            <a:fillRect/>
-          </a:stretch>
-        </p:blipFill>
-        <p:spPr>
-          <a:xfrm>
-            <a:off x="8458200" y="11029950"/>
-            <a:ext cx="1143000" cy="990600"/>
-          </a:xfrm>
-          <a:prstGeom prst="rect">
-            <a:avLst/>
-          </a:prstGeom>
-        </p:spPr>
-      </p:pic>
-    </p:spTree>
-  </p:cSld>
-  <p:clrMapOvr>
-    <a:masterClrMapping/>
-  </p:clrMapOvr>
-</p:sld>
-</file>
-
-<file path=ppt/slides/slide4.xml><?xml version="1.0" encoding="utf-8"?>
-<p:sld xmlns:a="http://schemas.openxmlformats.org/drawingml/2006/main" xmlns:p="http://schemas.openxmlformats.org/presentationml/2006/main" xmlns:r="http://schemas.openxmlformats.org/officeDocument/2006/relationships">
-  <p:cSld>
-    <p:bg>
-      <p:bgPr>
-        <a:solidFill>
-          <a:srgbClr val="DDE5D4"/>
-        </a:solidFill>
-        <a:effectLst/>
-      </p:bgPr>
-    </p:bg>
-    <p:spTree>
-      <p:nvGrpSpPr>
-        <p:cNvPr id="1" name=""/>
-        <p:cNvGrpSpPr/>
-        <p:nvPr/>
-      </p:nvGrpSpPr>
-      <p:grpSpPr/>
-      <p:pic>
-        <p:nvPicPr>
-          <p:cNvPr id="2" name="Picture 1" descr="_s03-11-2026-costa-rica-early-bird4_0.jpg"/>
-          <p:cNvPicPr>
-            <a:picLocks noChangeAspect="1"/>
-          </p:cNvPicPr>
-          <p:nvPr/>
-        </p:nvPicPr>
-        <p:blipFill>
-          <a:blip r:embed="rId2"/>
-          <a:stretch>
-            <a:fillRect/>
-          </a:stretch>
-        </p:blipFill>
-        <p:spPr>
-          <a:xfrm>
-            <a:off x="0" y="0"/>
-            <a:ext cx="10287000" cy="8191500"/>
-          </a:xfrm>
-          <a:prstGeom prst="rect">
-            <a:avLst/>
-          </a:prstGeom>
-        </p:spPr>
-      </p:pic>
-      <p:sp>
-        <p:nvSpPr>
-          <p:cNvPr id="3" name="Rectangle 2"/>
-          <p:cNvSpPr/>
-          <p:nvPr/>
-        </p:nvSpPr>
-        <p:spPr>
-          <a:xfrm>
-            <a:off x="685800" y="6667500"/>
-            <a:ext cx="8915400" cy="4095750"/>
+            <a:off x="0" y="7905750"/>
+            <a:ext cx="3810000" cy="3810000"/>
           </a:xfrm>
           <a:prstGeom prst="rect">
             <a:avLst/>
           </a:prstGeom>
           <a:solidFill>
-            <a:srgbClr val="22371F"/>
+            <a:srgbClr val="156826"/>
           </a:solidFill>
           <a:ln>
             <a:noFill/>
@@ -3887,14 +4127,58 @@
       </p:sp>
       <p:sp>
         <p:nvSpPr>
-          <p:cNvPr id="4" name="TextBox 3"/>
+          <p:cNvPr id="4" name="green band slide 2"/>
+          <p:cNvSpPr/>
+          <p:nvPr/>
+        </p:nvSpPr>
+        <p:spPr>
+          <a:xfrm>
+            <a:off x="0" y="0"/>
+            <a:ext cx="3810000" cy="12858750"/>
+          </a:xfrm>
+          <a:prstGeom prst="rect">
+            <a:avLst/>
+          </a:prstGeom>
+          <a:solidFill>
+            <a:srgbClr val="156826"/>
+          </a:solidFill>
+          <a:ln>
+            <a:noFill/>
+          </a:ln>
+          <a:effectLst/>
+        </p:spPr>
+        <p:style>
+          <a:lnRef idx="1">
+            <a:schemeClr val="accent1"/>
+          </a:lnRef>
+          <a:fillRef idx="3">
+            <a:schemeClr val="accent1"/>
+          </a:fillRef>
+          <a:effectRef idx="2">
+            <a:schemeClr val="accent1"/>
+          </a:effectRef>
+          <a:fontRef idx="minor">
+            <a:schemeClr val="lt1"/>
+          </a:fontRef>
+        </p:style>
+        <p:txBody>
+          <a:bodyPr rtlCol="0" anchor="ctr"/>
+          <a:lstStyle/>
+          <a:p>
+            <a:pPr algn="ctr"/>
+          </a:p>
+        </p:txBody>
+      </p:sp>
+      <p:sp>
+        <p:nvSpPr>
+          <p:cNvPr id="5" name="headline"/>
           <p:cNvSpPr txBox="1"/>
           <p:nvPr/>
         </p:nvSpPr>
         <p:spPr>
           <a:xfrm>
-            <a:off x="1162050" y="7143750"/>
-            <a:ext cx="6724650" cy="1535430"/>
+            <a:off x="381000" y="2857500"/>
+            <a:ext cx="3238500" cy="4953000"/>
           </a:xfrm>
           <a:prstGeom prst="rect">
             <a:avLst/>
@@ -3909,63 +4193,42 @@
           <a:p>
             <a:pPr algn="l">
               <a:lnSpc>
-                <a:spcPct val="88560"/>
+                <a:spcPct val="105000"/>
               </a:lnSpc>
             </a:pPr>
             <a:r>
-              <a:rPr sz="5250" b="0">
+              <a:rPr sz="4350" b="1">
                 <a:solidFill>
                   <a:srgbClr val="F4F1EA"/>
                 </a:solidFill>
-                <a:latin typeface="Fredoka"/>
-              </a:rPr>
-              <a:t>The microscope, every day.</a:t>
-            </a:r>
-          </a:p>
-        </p:txBody>
-      </p:sp>
-      <p:sp>
-        <p:nvSpPr>
-          <p:cNvPr id="5" name="TextBox 4"/>
-          <p:cNvSpPr txBox="1"/>
-          <p:nvPr/>
-        </p:nvSpPr>
-        <p:spPr>
-          <a:xfrm>
-            <a:off x="1162050" y="8907780"/>
-            <a:ext cx="6724650" cy="948690"/>
-          </a:xfrm>
-          <a:prstGeom prst="rect">
-            <a:avLst/>
-          </a:prstGeom>
-          <a:noFill/>
-        </p:spPr>
-        <p:txBody>
-          <a:bodyPr wrap="square" lIns="0" rIns="0" tIns="0" bIns="0" anchor="t">
-            <a:spAutoFit/>
-          </a:bodyPr>
-          <a:lstStyle/>
-          <a:p>
-            <a:pPr algn="l">
-              <a:lnSpc>
-                <a:spcPct val="114800"/>
-              </a:lnSpc>
-            </a:pPr>
-            <a:r>
-              <a:rPr sz="2400" b="0">
-                <a:solidFill>
-                  <a:srgbClr val="DDE5D4"/>
-                </a:solidFill>
                 <a:latin typeface="Montserrat"/>
               </a:rPr>
-              <a:t>The early bird ends 4 November. Register, link in bio.</a:t>
-            </a:r>
-          </a:p>
-        </p:txBody>
-      </p:sp>
+              <a:t>Ten days of hands‑on training</a:t>
+            </a:r>
+          </a:p>
+        </p:txBody>
+      </p:sp>
+    </p:spTree>
+  </p:cSld>
+  <p:clrMapOvr>
+    <a:masterClrMapping/>
+  </p:clrMapOvr>
+</p:sld>
+</file>
+
+<file path=ppt/slides/slide3.xml><?xml version="1.0" encoding="utf-8"?>
+<p:sld xmlns:a="http://schemas.openxmlformats.org/drawingml/2006/main" xmlns:p="http://schemas.openxmlformats.org/presentationml/2006/main" xmlns:r="http://schemas.openxmlformats.org/officeDocument/2006/relationships">
+  <p:cSld>
+    <p:spTree>
+      <p:nvGrpSpPr>
+        <p:cNvPr id="1" name=""/>
+        <p:cNvGrpSpPr/>
+        <p:nvPr/>
+      </p:nvGrpSpPr>
+      <p:grpSpPr/>
       <p:pic>
         <p:nvPicPr>
-          <p:cNvPr id="6" name="Picture 5" descr="hibiscus-sh.png"/>
+          <p:cNvPr id="2" name="photo HandsInSoil" descr="image.jpg"/>
           <p:cNvPicPr>
             <a:picLocks noChangeAspect="1"/>
           </p:cNvPicPr>
@@ -3979,8 +4242,133 @@
         </p:blipFill>
         <p:spPr>
           <a:xfrm>
-            <a:off x="8001000" y="5619750"/>
-            <a:ext cx="1781175" cy="2000250"/>
+            <a:off x="0" y="0"/>
+            <a:ext cx="10287000" cy="7905750"/>
+          </a:xfrm>
+          <a:prstGeom prst="rect">
+            <a:avLst/>
+          </a:prstGeom>
+        </p:spPr>
+      </p:pic>
+      <p:sp>
+        <p:nvSpPr>
+          <p:cNvPr id="3" name="soil brown box"/>
+          <p:cNvSpPr/>
+          <p:nvPr/>
+        </p:nvSpPr>
+        <p:spPr>
+          <a:xfrm>
+            <a:off x="0" y="7239000"/>
+            <a:ext cx="10287000" cy="5619750"/>
+          </a:xfrm>
+          <a:prstGeom prst="rect">
+            <a:avLst/>
+          </a:prstGeom>
+          <a:solidFill>
+            <a:srgbClr val="4F3433"/>
+          </a:solidFill>
+          <a:ln>
+            <a:noFill/>
+          </a:ln>
+          <a:effectLst/>
+        </p:spPr>
+        <p:style>
+          <a:lnRef idx="1">
+            <a:schemeClr val="accent1"/>
+          </a:lnRef>
+          <a:fillRef idx="3">
+            <a:schemeClr val="accent1"/>
+          </a:fillRef>
+          <a:effectRef idx="2">
+            <a:schemeClr val="accent1"/>
+          </a:effectRef>
+          <a:fontRef idx="minor">
+            <a:schemeClr val="lt1"/>
+          </a:fontRef>
+        </p:style>
+        <p:txBody>
+          <a:bodyPr rtlCol="0" anchor="ctr"/>
+          <a:lstStyle/>
+          <a:p>
+            <a:pPr algn="ctr"/>
+          </a:p>
+        </p:txBody>
+      </p:sp>
+      <p:sp>
+        <p:nvSpPr>
+          <p:cNvPr id="4" name="headline"/>
+          <p:cNvSpPr txBox="1"/>
+          <p:nvPr/>
+        </p:nvSpPr>
+        <p:spPr>
+          <a:xfrm>
+            <a:off x="762000" y="8191500"/>
+            <a:ext cx="8572500" cy="3619500"/>
+          </a:xfrm>
+          <a:prstGeom prst="rect">
+            <a:avLst/>
+          </a:prstGeom>
+          <a:noFill/>
+        </p:spPr>
+        <p:txBody>
+          <a:bodyPr wrap="square" lIns="0" rIns="0" tIns="0" bIns="0" anchor="t">
+            <a:spAutoFit/>
+          </a:bodyPr>
+          <a:lstStyle/>
+          <a:p>
+            <a:pPr algn="l">
+              <a:lnSpc>
+                <a:spcPct val="105000"/>
+              </a:lnSpc>
+            </a:pPr>
+            <a:r>
+              <a:rPr sz="5400" b="1">
+                <a:solidFill>
+                  <a:srgbClr val="F4F1EA"/>
+                </a:solidFill>
+                <a:latin typeface="Montserrat"/>
+              </a:rPr>
+              <a:t>Build BioComplete™ compost with your team</a:t>
+            </a:r>
+          </a:p>
+        </p:txBody>
+      </p:sp>
+    </p:spTree>
+  </p:cSld>
+  <p:clrMapOvr>
+    <a:masterClrMapping/>
+  </p:clrMapOvr>
+</p:sld>
+</file>
+
+<file path=ppt/slides/slide4.xml><?xml version="1.0" encoding="utf-8"?>
+<p:sld xmlns:a="http://schemas.openxmlformats.org/drawingml/2006/main" xmlns:p="http://schemas.openxmlformats.org/presentationml/2006/main" xmlns:r="http://schemas.openxmlformats.org/officeDocument/2006/relationships">
+  <p:cSld>
+    <p:spTree>
+      <p:nvGrpSpPr>
+        <p:cNvPr id="1" name=""/>
+        <p:cNvGrpSpPr/>
+        <p:nvPr/>
+      </p:nvGrpSpPr>
+      <p:grpSpPr/>
+      <p:pic>
+        <p:nvPicPr>
+          <p:cNvPr id="2" name="photo PXL_20251020_222404850" descr="image.jpg"/>
+          <p:cNvPicPr>
+            <a:picLocks noChangeAspect="1"/>
+          </p:cNvPicPr>
+          <p:nvPr/>
+        </p:nvPicPr>
+        <p:blipFill>
+          <a:blip r:embed="rId3"/>
+          <a:stretch>
+            <a:fillRect/>
+          </a:stretch>
+        </p:blipFill>
+        <p:spPr>
+          <a:xfrm>
+            <a:off x="0" y="0"/>
+            <a:ext cx="10287000" cy="6429375"/>
           </a:xfrm>
           <a:prstGeom prst="rect">
             <a:avLst/>
@@ -3989,7 +4377,7 @@
       </p:pic>
       <p:pic>
         <p:nvPicPr>
-          <p:cNvPr id="7" name="Picture 6" descr="logo.png"/>
+          <p:cNvPr id="3" name="photo Compost Tea Prep" descr="image.jpg"/>
           <p:cNvPicPr>
             <a:picLocks noChangeAspect="1"/>
           </p:cNvPicPr>
@@ -4003,8 +4391,482 @@
         </p:blipFill>
         <p:spPr>
           <a:xfrm>
-            <a:off x="8458200" y="11029950"/>
-            <a:ext cx="1143000" cy="990600"/>
+            <a:off x="0" y="6429375"/>
+            <a:ext cx="10287000" cy="6429375"/>
+          </a:xfrm>
+          <a:prstGeom prst="rect">
+            <a:avLst/>
+          </a:prstGeom>
+        </p:spPr>
+      </p:pic>
+      <p:sp>
+        <p:nvSpPr>
+          <p:cNvPr id="4" name="cream box"/>
+          <p:cNvSpPr/>
+          <p:nvPr/>
+        </p:nvSpPr>
+        <p:spPr>
+          <a:xfrm>
+            <a:off x="1333500" y="5191125"/>
+            <a:ext cx="8953500" cy="2476500"/>
+          </a:xfrm>
+          <a:prstGeom prst="rect">
+            <a:avLst/>
+          </a:prstGeom>
+          <a:solidFill>
+            <a:srgbClr val="F4F1EA"/>
+          </a:solidFill>
+          <a:ln>
+            <a:noFill/>
+          </a:ln>
+          <a:effectLst/>
+        </p:spPr>
+        <p:style>
+          <a:lnRef idx="1">
+            <a:schemeClr val="accent1"/>
+          </a:lnRef>
+          <a:fillRef idx="3">
+            <a:schemeClr val="accent1"/>
+          </a:fillRef>
+          <a:effectRef idx="2">
+            <a:schemeClr val="accent1"/>
+          </a:effectRef>
+          <a:fontRef idx="minor">
+            <a:schemeClr val="lt1"/>
+          </a:fontRef>
+        </p:style>
+        <p:txBody>
+          <a:bodyPr rtlCol="0" anchor="ctr"/>
+          <a:lstStyle/>
+          <a:p>
+            <a:pPr algn="ctr"/>
+          </a:p>
+        </p:txBody>
+      </p:sp>
+      <p:sp>
+        <p:nvSpPr>
+          <p:cNvPr id="5" name="headline"/>
+          <p:cNvSpPr txBox="1"/>
+          <p:nvPr/>
+        </p:nvSpPr>
+        <p:spPr>
+          <a:xfrm>
+            <a:off x="1905000" y="5191125"/>
+            <a:ext cx="8001000" cy="2476500"/>
+          </a:xfrm>
+          <a:prstGeom prst="rect">
+            <a:avLst/>
+          </a:prstGeom>
+          <a:noFill/>
+        </p:spPr>
+        <p:txBody>
+          <a:bodyPr wrap="square" lIns="0" rIns="0" tIns="0" bIns="0" anchor="ctr">
+            <a:spAutoFit/>
+          </a:bodyPr>
+          <a:lstStyle/>
+          <a:p>
+            <a:pPr algn="l">
+              <a:lnSpc>
+                <a:spcPct val="105000"/>
+              </a:lnSpc>
+            </a:pPr>
+            <a:r>
+              <a:rPr sz="5550" b="1">
+                <a:solidFill>
+                  <a:srgbClr val="4F3433"/>
+                </a:solidFill>
+                <a:latin typeface="Montserrat"/>
+              </a:rPr>
+              <a:t>Brew extracts and teas</a:t>
+            </a:r>
+          </a:p>
+        </p:txBody>
+      </p:sp>
+    </p:spTree>
+  </p:cSld>
+  <p:clrMapOvr>
+    <a:masterClrMapping/>
+  </p:clrMapOvr>
+</p:sld>
+</file>
+
+<file path=ppt/slides/slide5.xml><?xml version="1.0" encoding="utf-8"?>
+<p:sld xmlns:a="http://schemas.openxmlformats.org/drawingml/2006/main" xmlns:p="http://schemas.openxmlformats.org/presentationml/2006/main" xmlns:r="http://schemas.openxmlformats.org/officeDocument/2006/relationships">
+  <p:cSld>
+    <p:spTree>
+      <p:nvGrpSpPr>
+        <p:cNvPr id="1" name=""/>
+        <p:cNvGrpSpPr/>
+        <p:nvPr/>
+      </p:nvGrpSpPr>
+      <p:grpSpPr/>
+      <p:pic>
+        <p:nvPicPr>
+          <p:cNvPr id="2" name="photo PXL_20251023_191907277" descr="image.jpg"/>
+          <p:cNvPicPr>
+            <a:picLocks noChangeAspect="1"/>
+          </p:cNvPicPr>
+          <p:nvPr/>
+        </p:nvPicPr>
+        <p:blipFill>
+          <a:blip r:embed="rId3"/>
+          <a:stretch>
+            <a:fillRect/>
+          </a:stretch>
+        </p:blipFill>
+        <p:spPr>
+          <a:xfrm>
+            <a:off x="0" y="0"/>
+            <a:ext cx="10287000" cy="12858750"/>
+          </a:xfrm>
+          <a:prstGeom prst="rect">
+            <a:avLst/>
+          </a:prstGeom>
+        </p:spPr>
+      </p:pic>
+      <p:sp>
+        <p:nvSpPr>
+          <p:cNvPr id="3" name="education blue box"/>
+          <p:cNvSpPr/>
+          <p:nvPr/>
+        </p:nvSpPr>
+        <p:spPr>
+          <a:xfrm>
+            <a:off x="0" y="0"/>
+            <a:ext cx="7239000" cy="4476750"/>
+          </a:xfrm>
+          <a:prstGeom prst="rect">
+            <a:avLst/>
+          </a:prstGeom>
+          <a:solidFill>
+            <a:srgbClr val="3780B8"/>
+          </a:solidFill>
+          <a:ln>
+            <a:noFill/>
+          </a:ln>
+          <a:effectLst/>
+        </p:spPr>
+        <p:style>
+          <a:lnRef idx="1">
+            <a:schemeClr val="accent1"/>
+          </a:lnRef>
+          <a:fillRef idx="3">
+            <a:schemeClr val="accent1"/>
+          </a:fillRef>
+          <a:effectRef idx="2">
+            <a:schemeClr val="accent1"/>
+          </a:effectRef>
+          <a:fontRef idx="minor">
+            <a:schemeClr val="lt1"/>
+          </a:fontRef>
+        </p:style>
+        <p:txBody>
+          <a:bodyPr rtlCol="0" anchor="ctr"/>
+          <a:lstStyle/>
+          <a:p>
+            <a:pPr algn="ctr"/>
+          </a:p>
+        </p:txBody>
+      </p:sp>
+      <p:sp>
+        <p:nvSpPr>
+          <p:cNvPr id="4" name="headline"/>
+          <p:cNvSpPr txBox="1"/>
+          <p:nvPr/>
+        </p:nvSpPr>
+        <p:spPr>
+          <a:xfrm>
+            <a:off x="666750" y="857250"/>
+            <a:ext cx="6096000" cy="3238500"/>
+          </a:xfrm>
+          <a:prstGeom prst="rect">
+            <a:avLst/>
+          </a:prstGeom>
+          <a:noFill/>
+        </p:spPr>
+        <p:txBody>
+          <a:bodyPr wrap="square" lIns="0" rIns="0" tIns="0" bIns="0" anchor="t">
+            <a:spAutoFit/>
+          </a:bodyPr>
+          <a:lstStyle/>
+          <a:p>
+            <a:pPr algn="l">
+              <a:lnSpc>
+                <a:spcPct val="105000"/>
+              </a:lnSpc>
+            </a:pPr>
+            <a:r>
+              <a:rPr sz="4950" b="1">
+                <a:solidFill>
+                  <a:srgbClr val="F4F1EA"/>
+                </a:solidFill>
+                <a:latin typeface="Montserrat"/>
+              </a:rPr>
+              <a:t>Read the biology, with a mentor beside you</a:t>
+            </a:r>
+          </a:p>
+        </p:txBody>
+      </p:sp>
+    </p:spTree>
+  </p:cSld>
+  <p:clrMapOvr>
+    <a:masterClrMapping/>
+  </p:clrMapOvr>
+</p:sld>
+</file>
+
+<file path=ppt/slides/slide6.xml><?xml version="1.0" encoding="utf-8"?>
+<p:sld xmlns:a="http://schemas.openxmlformats.org/drawingml/2006/main" xmlns:p="http://schemas.openxmlformats.org/presentationml/2006/main" xmlns:r="http://schemas.openxmlformats.org/officeDocument/2006/relationships">
+  <p:cSld>
+    <p:spTree>
+      <p:nvGrpSpPr>
+        <p:cNvPr id="1" name=""/>
+        <p:cNvGrpSpPr/>
+        <p:nvPr/>
+      </p:nvGrpSpPr>
+      <p:grpSpPr/>
+      <p:pic>
+        <p:nvPicPr>
+          <p:cNvPr id="2" name="photo PXL_20251022_172210012" descr="image.jpg"/>
+          <p:cNvPicPr>
+            <a:picLocks noChangeAspect="1"/>
+          </p:cNvPicPr>
+          <p:nvPr/>
+        </p:nvPicPr>
+        <p:blipFill>
+          <a:blip r:embed="rId3"/>
+          <a:stretch>
+            <a:fillRect/>
+          </a:stretch>
+        </p:blipFill>
+        <p:spPr>
+          <a:xfrm>
+            <a:off x="0" y="0"/>
+            <a:ext cx="10287000" cy="12858750"/>
+          </a:xfrm>
+          <a:prstGeom prst="rect">
+            <a:avLst/>
+          </a:prstGeom>
+        </p:spPr>
+      </p:pic>
+      <p:sp>
+        <p:nvSpPr>
+          <p:cNvPr id="3" name="green box"/>
+          <p:cNvSpPr/>
+          <p:nvPr/>
+        </p:nvSpPr>
+        <p:spPr>
+          <a:xfrm>
+            <a:off x="857250" y="7048500"/>
+            <a:ext cx="8572500" cy="5143500"/>
+          </a:xfrm>
+          <a:prstGeom prst="rect">
+            <a:avLst/>
+          </a:prstGeom>
+          <a:solidFill>
+            <a:srgbClr val="156826"/>
+          </a:solidFill>
+          <a:ln>
+            <a:noFill/>
+          </a:ln>
+          <a:effectLst/>
+        </p:spPr>
+        <p:style>
+          <a:lnRef idx="1">
+            <a:schemeClr val="accent1"/>
+          </a:lnRef>
+          <a:fillRef idx="3">
+            <a:schemeClr val="accent1"/>
+          </a:fillRef>
+          <a:effectRef idx="2">
+            <a:schemeClr val="accent1"/>
+          </a:effectRef>
+          <a:fontRef idx="minor">
+            <a:schemeClr val="lt1"/>
+          </a:fontRef>
+        </p:style>
+        <p:txBody>
+          <a:bodyPr rtlCol="0" anchor="ctr"/>
+          <a:lstStyle/>
+          <a:p>
+            <a:pPr algn="ctr"/>
+          </a:p>
+        </p:txBody>
+      </p:sp>
+      <p:sp>
+        <p:nvSpPr>
+          <p:cNvPr id="4" name="title"/>
+          <p:cNvSpPr txBox="1"/>
+          <p:nvPr/>
+        </p:nvSpPr>
+        <p:spPr>
+          <a:xfrm>
+            <a:off x="1428750" y="7524750"/>
+            <a:ext cx="7620000" cy="762000"/>
+          </a:xfrm>
+          <a:prstGeom prst="rect">
+            <a:avLst/>
+          </a:prstGeom>
+          <a:noFill/>
+        </p:spPr>
+        <p:txBody>
+          <a:bodyPr wrap="square" lIns="0" rIns="0" tIns="0" bIns="0" anchor="t">
+            <a:spAutoFit/>
+          </a:bodyPr>
+          <a:lstStyle/>
+          <a:p>
+            <a:pPr algn="l">
+              <a:lnSpc>
+                <a:spcPct val="105000"/>
+              </a:lnSpc>
+            </a:pPr>
+            <a:r>
+              <a:rPr sz="4350" b="1">
+                <a:solidFill>
+                  <a:srgbClr val="F4F1EA"/>
+                </a:solidFill>
+                <a:latin typeface="Montserrat"/>
+              </a:rPr>
+              <a:t>Accelerator Workshop</a:t>
+            </a:r>
+          </a:p>
+        </p:txBody>
+      </p:sp>
+      <p:sp>
+        <p:nvSpPr>
+          <p:cNvPr id="5" name="place"/>
+          <p:cNvSpPr txBox="1"/>
+          <p:nvPr/>
+        </p:nvSpPr>
+        <p:spPr>
+          <a:xfrm>
+            <a:off x="1447800" y="8524875"/>
+            <a:ext cx="7239000" cy="571500"/>
+          </a:xfrm>
+          <a:prstGeom prst="rect">
+            <a:avLst/>
+          </a:prstGeom>
+          <a:noFill/>
+        </p:spPr>
+        <p:txBody>
+          <a:bodyPr wrap="square" lIns="0" rIns="0" tIns="0" bIns="0" anchor="t">
+            <a:spAutoFit/>
+          </a:bodyPr>
+          <a:lstStyle/>
+          <a:p>
+            <a:pPr algn="l">
+              <a:lnSpc>
+                <a:spcPct val="105000"/>
+              </a:lnSpc>
+            </a:pPr>
+            <a:r>
+              <a:rPr sz="3300" b="0">
+                <a:solidFill>
+                  <a:srgbClr val="F4F1EA"/>
+                </a:solidFill>
+                <a:latin typeface="Source Sans 3"/>
+              </a:rPr>
+              <a:t>Heredia, Costa Rica</a:t>
+            </a:r>
+          </a:p>
+        </p:txBody>
+      </p:sp>
+      <p:sp>
+        <p:nvSpPr>
+          <p:cNvPr id="6" name="dates"/>
+          <p:cNvSpPr txBox="1"/>
+          <p:nvPr/>
+        </p:nvSpPr>
+        <p:spPr>
+          <a:xfrm>
+            <a:off x="1447800" y="9096375"/>
+            <a:ext cx="7239000" cy="571500"/>
+          </a:xfrm>
+          <a:prstGeom prst="rect">
+            <a:avLst/>
+          </a:prstGeom>
+          <a:noFill/>
+        </p:spPr>
+        <p:txBody>
+          <a:bodyPr wrap="square" lIns="0" rIns="0" tIns="0" bIns="0" anchor="t">
+            <a:spAutoFit/>
+          </a:bodyPr>
+          <a:lstStyle/>
+          <a:p>
+            <a:pPr algn="l">
+              <a:lnSpc>
+                <a:spcPct val="105000"/>
+              </a:lnSpc>
+            </a:pPr>
+            <a:r>
+              <a:rPr sz="3300" b="0">
+                <a:solidFill>
+                  <a:srgbClr val="F4F1EA"/>
+                </a:solidFill>
+                <a:latin typeface="Source Sans 3"/>
+              </a:rPr>
+              <a:t>January 18–29, 2027</a:t>
+            </a:r>
+          </a:p>
+        </p:txBody>
+      </p:sp>
+      <p:sp>
+        <p:nvSpPr>
+          <p:cNvPr id="7" name="cta"/>
+          <p:cNvSpPr txBox="1"/>
+          <p:nvPr/>
+        </p:nvSpPr>
+        <p:spPr>
+          <a:xfrm>
+            <a:off x="1428750" y="10525125"/>
+            <a:ext cx="5524500" cy="666750"/>
+          </a:xfrm>
+          <a:prstGeom prst="rect">
+            <a:avLst/>
+          </a:prstGeom>
+          <a:noFill/>
+        </p:spPr>
+        <p:txBody>
+          <a:bodyPr wrap="square" lIns="0" rIns="0" tIns="0" bIns="0" anchor="t">
+            <a:spAutoFit/>
+          </a:bodyPr>
+          <a:lstStyle/>
+          <a:p>
+            <a:pPr algn="l">
+              <a:lnSpc>
+                <a:spcPct val="105000"/>
+              </a:lnSpc>
+            </a:pPr>
+            <a:r>
+              <a:rPr sz="3600" b="1">
+                <a:solidFill>
+                  <a:srgbClr val="F4F1EA"/>
+                </a:solidFill>
+                <a:latin typeface="Montserrat"/>
+              </a:rPr>
+              <a:t>Register, link in bio</a:t>
+            </a:r>
+          </a:p>
+        </p:txBody>
+      </p:sp>
+      <p:pic>
+        <p:nvPicPr>
+          <p:cNvPr id="8" name="logo" descr="image.png"/>
+          <p:cNvPicPr>
+            <a:picLocks noChangeAspect="1"/>
+          </p:cNvPicPr>
+          <p:nvPr/>
+        </p:nvPicPr>
+        <p:blipFill>
+          <a:blip r:embed="rId4"/>
+          <a:stretch>
+            <a:fillRect/>
+          </a:stretch>
+        </p:blipFill>
+        <p:spPr>
+          <a:xfrm>
+            <a:off x="7524750" y="10287000"/>
+            <a:ext cx="1619250" cy="1619250"/>
           </a:xfrm>
           <a:prstGeom prst="rect">
             <a:avLst/>
@@ -4337,4 +5199,324 @@
   </a:objectDefaults>
   <a:extraClrSchemeLst/>
 </a:theme>
+</file>
+
+<file path=ppt/theme/theme2.xml><?xml version="1.0" encoding="utf-8"?>
+<a:theme xmlns:a="http://schemas.openxmlformats.org/drawingml/2006/main" name="Office Theme">
+  <a:themeElements>
+    <a:clrScheme name="Office">
+      <a:dk1>
+        <a:sysClr val="windowText" lastClr="000000"/>
+      </a:dk1>
+      <a:lt1>
+        <a:sysClr val="window" lastClr="FFFFFF"/>
+      </a:lt1>
+      <a:dk2>
+        <a:srgbClr val="1F497D"/>
+      </a:dk2>
+      <a:lt2>
+        <a:srgbClr val="EEECE1"/>
+      </a:lt2>
+      <a:accent1>
+        <a:srgbClr val="4F81BD"/>
+      </a:accent1>
+      <a:accent2>
+        <a:srgbClr val="C0504D"/>
+      </a:accent2>
+      <a:accent3>
+        <a:srgbClr val="9BBB59"/>
+      </a:accent3>
+      <a:accent4>
+        <a:srgbClr val="8064A2"/>
+      </a:accent4>
+      <a:accent5>
+        <a:srgbClr val="4BACC6"/>
+      </a:accent5>
+      <a:accent6>
+        <a:srgbClr val="F79646"/>
+      </a:accent6>
+      <a:hlink>
+        <a:srgbClr val="0000FF"/>
+      </a:hlink>
+      <a:folHlink>
+        <a:srgbClr val="800080"/>
+      </a:folHlink>
+    </a:clrScheme>
+    <a:fontScheme name="Office">
+      <a:majorFont>
+        <a:latin typeface="Calibri"/>
+        <a:ea typeface=""/>
+        <a:cs typeface=""/>
+        <a:font script="Jpan" typeface="ＭＳ Ｐゴシック"/>
+        <a:font script="Hang" typeface="맑은 고딕"/>
+        <a:font script="Hans" typeface="宋体"/>
+        <a:font script="Hant" typeface="新細明體"/>
+        <a:font script="Arab" typeface="Times New Roman"/>
+        <a:font script="Hebr" typeface="Times New Roman"/>
+        <a:font script="Thai" typeface="Angsana New"/>
+        <a:font script="Ethi" typeface="Nyala"/>
+        <a:font script="Beng" typeface="Vrinda"/>
+        <a:font script="Gujr" typeface="Shruti"/>
+        <a:font script="Khmr" typeface="MoolBoran"/>
+        <a:font script="Knda" typeface="Tunga"/>
+        <a:font script="Guru" typeface="Raavi"/>
+        <a:font script="Cans" typeface="Euphemia"/>
+        <a:font script="Cher" typeface="Plantagenet Cherokee"/>
+        <a:font script="Yiii" typeface="Microsoft Yi Baiti"/>
+        <a:font script="Tibt" typeface="Microsoft Himalaya"/>
+        <a:font script="Thaa" typeface="MV Boli"/>
+        <a:font script="Deva" typeface="Mangal"/>
+        <a:font script="Telu" typeface="Gautami"/>
+        <a:font script="Taml" typeface="Latha"/>
+        <a:font script="Syrc" typeface="Estrangelo Edessa"/>
+        <a:font script="Orya" typeface="Kalinga"/>
+        <a:font script="Mlym" typeface="Kartika"/>
+        <a:font script="Laoo" typeface="DokChampa"/>
+        <a:font script="Sinh" typeface="Iskoola Pota"/>
+        <a:font script="Mong" typeface="Mongolian Baiti"/>
+        <a:font script="Viet" typeface="Times New Roman"/>
+        <a:font script="Uigh" typeface="Microsoft Uighur"/>
+        <a:font script="Geor" typeface="Sylfaen"/>
+      </a:majorFont>
+      <a:minorFont>
+        <a:latin typeface="Calibri"/>
+        <a:ea typeface=""/>
+        <a:cs typeface=""/>
+        <a:font script="Jpan" typeface="ＭＳ Ｐゴシック"/>
+        <a:font script="Hang" typeface="맑은 고딕"/>
+        <a:font script="Hans" typeface="宋体"/>
+        <a:font script="Hant" typeface="新細明體"/>
+        <a:font script="Arab" typeface="Arial"/>
+        <a:font script="Hebr" typeface="Arial"/>
+        <a:font script="Thai" typeface="Cordia New"/>
+        <a:font script="Ethi" typeface="Nyala"/>
+        <a:font script="Beng" typeface="Vrinda"/>
+        <a:font script="Gujr" typeface="Shruti"/>
+        <a:font script="Khmr" typeface="DaunPenh"/>
+        <a:font script="Knda" typeface="Tunga"/>
+        <a:font script="Guru" typeface="Raavi"/>
+        <a:font script="Cans" typeface="Euphemia"/>
+        <a:font script="Cher" typeface="Plantagenet Cherokee"/>
+        <a:font script="Yiii" typeface="Microsoft Yi Baiti"/>
+        <a:font script="Tibt" typeface="Microsoft Himalaya"/>
+        <a:font script="Thaa" typeface="MV Boli"/>
+        <a:font script="Deva" typeface="Mangal"/>
+        <a:font script="Telu" typeface="Gautami"/>
+        <a:font script="Taml" typeface="Latha"/>
+        <a:font script="Syrc" typeface="Estrangelo Edessa"/>
+        <a:font script="Orya" typeface="Kalinga"/>
+        <a:font script="Mlym" typeface="Kartika"/>
+        <a:font script="Laoo" typeface="DokChampa"/>
+        <a:font script="Sinh" typeface="Iskoola Pota"/>
+        <a:font script="Mong" typeface="Mongolian Baiti"/>
+        <a:font script="Viet" typeface="Arial"/>
+        <a:font script="Uigh" typeface="Microsoft Uighur"/>
+        <a:font script="Geor" typeface="Sylfaen"/>
+      </a:minorFont>
+    </a:fontScheme>
+    <a:fmtScheme name="Office">
+      <a:fillStyleLst>
+        <a:solidFill>
+          <a:schemeClr val="phClr"/>
+        </a:solidFill>
+        <a:gradFill rotWithShape="1">
+          <a:gsLst>
+            <a:gs pos="0">
+              <a:schemeClr val="phClr">
+                <a:tint val="50000"/>
+                <a:satMod val="300000"/>
+              </a:schemeClr>
+            </a:gs>
+            <a:gs pos="35000">
+              <a:schemeClr val="phClr">
+                <a:tint val="37000"/>
+                <a:satMod val="300000"/>
+              </a:schemeClr>
+            </a:gs>
+            <a:gs pos="100000">
+              <a:schemeClr val="phClr">
+                <a:tint val="15000"/>
+                <a:satMod val="350000"/>
+              </a:schemeClr>
+            </a:gs>
+          </a:gsLst>
+          <a:lin ang="16200000" scaled="1"/>
+        </a:gradFill>
+        <a:gradFill rotWithShape="1">
+          <a:gsLst>
+            <a:gs pos="0">
+              <a:schemeClr val="phClr">
+                <a:tint val="100000"/>
+                <a:shade val="100000"/>
+                <a:satMod val="130000"/>
+              </a:schemeClr>
+            </a:gs>
+            <a:gs pos="100000">
+              <a:schemeClr val="phClr">
+                <a:tint val="50000"/>
+                <a:shade val="100000"/>
+                <a:satMod val="350000"/>
+              </a:schemeClr>
+            </a:gs>
+          </a:gsLst>
+          <a:lin ang="16200000" scaled="0"/>
+        </a:gradFill>
+      </a:fillStyleLst>
+      <a:lnStyleLst>
+        <a:ln w="9525" cap="flat" cmpd="sng" algn="ctr">
+          <a:solidFill>
+            <a:schemeClr val="phClr">
+              <a:shade val="95000"/>
+              <a:satMod val="105000"/>
+            </a:schemeClr>
+          </a:solidFill>
+          <a:prstDash val="solid"/>
+        </a:ln>
+        <a:ln w="25400" cap="flat" cmpd="sng" algn="ctr">
+          <a:solidFill>
+            <a:schemeClr val="phClr"/>
+          </a:solidFill>
+          <a:prstDash val="solid"/>
+        </a:ln>
+        <a:ln w="38100" cap="flat" cmpd="sng" algn="ctr">
+          <a:solidFill>
+            <a:schemeClr val="phClr"/>
+          </a:solidFill>
+          <a:prstDash val="solid"/>
+        </a:ln>
+      </a:lnStyleLst>
+      <a:effectStyleLst>
+        <a:effectStyle>
+          <a:effectLst>
+            <a:outerShdw blurRad="40000" dist="20000" dir="5400000" rotWithShape="0">
+              <a:srgbClr val="000000">
+                <a:alpha val="38000"/>
+              </a:srgbClr>
+            </a:outerShdw>
+          </a:effectLst>
+        </a:effectStyle>
+        <a:effectStyle>
+          <a:effectLst>
+            <a:outerShdw blurRad="40000" dist="23000" dir="5400000" rotWithShape="0">
+              <a:srgbClr val="000000">
+                <a:alpha val="35000"/>
+              </a:srgbClr>
+            </a:outerShdw>
+          </a:effectLst>
+        </a:effectStyle>
+        <a:effectStyle>
+          <a:effectLst>
+            <a:outerShdw blurRad="40000" dist="23000" dir="5400000" rotWithShape="0">
+              <a:srgbClr val="000000">
+                <a:alpha val="35000"/>
+              </a:srgbClr>
+            </a:outerShdw>
+          </a:effectLst>
+          <a:scene3d>
+            <a:camera prst="orthographicFront">
+              <a:rot lat="0" lon="0" rev="0"/>
+            </a:camera>
+            <a:lightRig rig="threePt" dir="t">
+              <a:rot lat="0" lon="0" rev="1200000"/>
+            </a:lightRig>
+          </a:scene3d>
+          <a:sp3d>
+            <a:bevelT w="63500" h="25400"/>
+          </a:sp3d>
+        </a:effectStyle>
+      </a:effectStyleLst>
+      <a:bgFillStyleLst>
+        <a:solidFill>
+          <a:schemeClr val="phClr"/>
+        </a:solidFill>
+        <a:gradFill rotWithShape="1">
+          <a:gsLst>
+            <a:gs pos="0">
+              <a:schemeClr val="phClr">
+                <a:tint val="40000"/>
+                <a:satMod val="350000"/>
+              </a:schemeClr>
+            </a:gs>
+            <a:gs pos="40000">
+              <a:schemeClr val="phClr">
+                <a:tint val="45000"/>
+                <a:shade val="99000"/>
+                <a:satMod val="350000"/>
+              </a:schemeClr>
+            </a:gs>
+            <a:gs pos="100000">
+              <a:schemeClr val="phClr">
+                <a:shade val="20000"/>
+                <a:satMod val="255000"/>
+              </a:schemeClr>
+            </a:gs>
+          </a:gsLst>
+          <a:path path="circle">
+            <a:fillToRect l="50000" t="-80000" r="50000" b="180000"/>
+          </a:path>
+        </a:gradFill>
+        <a:gradFill rotWithShape="1">
+          <a:gsLst>
+            <a:gs pos="0">
+              <a:schemeClr val="phClr">
+                <a:tint val="80000"/>
+                <a:satMod val="300000"/>
+              </a:schemeClr>
+            </a:gs>
+            <a:gs pos="100000">
+              <a:schemeClr val="phClr">
+                <a:shade val="30000"/>
+                <a:satMod val="200000"/>
+              </a:schemeClr>
+            </a:gs>
+          </a:gsLst>
+          <a:path path="circle">
+            <a:fillToRect l="50000" t="50000" r="50000" b="50000"/>
+          </a:path>
+        </a:gradFill>
+      </a:bgFillStyleLst>
+    </a:fmtScheme>
+  </a:themeElements>
+  <a:objectDefaults>
+    <a:spDef>
+      <a:spPr/>
+      <a:bodyPr/>
+      <a:lstStyle/>
+      <a:style>
+        <a:lnRef idx="1">
+          <a:schemeClr val="accent1"/>
+        </a:lnRef>
+        <a:fillRef idx="3">
+          <a:schemeClr val="accent1"/>
+        </a:fillRef>
+        <a:effectRef idx="2">
+          <a:schemeClr val="accent1"/>
+        </a:effectRef>
+        <a:fontRef idx="minor">
+          <a:schemeClr val="lt1"/>
+        </a:fontRef>
+      </a:style>
+    </a:spDef>
+    <a:lnDef>
+      <a:spPr/>
+      <a:bodyPr/>
+      <a:lstStyle/>
+      <a:style>
+        <a:lnRef idx="2">
+          <a:schemeClr val="accent1"/>
+        </a:lnRef>
+        <a:fillRef idx="0">
+          <a:schemeClr val="accent1"/>
+        </a:fillRef>
+        <a:effectRef idx="1">
+          <a:schemeClr val="accent1"/>
+        </a:effectRef>
+        <a:fontRef idx="minor">
+          <a:schemeClr val="tx1"/>
+        </a:fontRef>
+      </a:style>
+    </a:lnDef>
+  </a:objectDefaults>
+  <a:extraClrSchemeLst/>
+</a:theme>
 </file>
</xml_diff>